<commit_message>
Real timetable + national rail-network map (8,697 stations); plain-spoken copy; pitch/Q&A prep
</commit_message>
<xml_diff>
--- a/Pravaah-Deck.pptx
+++ b/Pravaah-Deck.pptx
@@ -3185,7 +3185,7 @@
                 </a:solidFill>
                 <a:latin typeface="Consolas"/>
               </a:rPr>
-              <a:t>FAR AWAY · 2026   ·   RAILWAYS</a:t>
+              <a:t>FAR AWAY 2026   ·   RAILWAYS</a:t>
             </a:r>
           </a:p>
           <a:p>
@@ -3233,7 +3233,7 @@
                 </a:solidFill>
                 <a:latin typeface="Segoe UI"/>
               </a:rPr>
-              <a:t>An open, explainable, real-time AI train re-dispatch copilot for the Indian Railways section controller.</a:t>
+              <a:t>An open, explainable AI co-pilot for the Indian Railways section controller.</a:t>
             </a:r>
           </a:p>
         </p:txBody>
@@ -3272,7 +3272,7 @@
                 </a:solidFill>
                 <a:latin typeface="Consolas"/>
               </a:rPr>
-              <a:t>github.com/garvitsurana271/pravaah   ·   maps to SIH25022   ·   Garvit Surana &amp; team</a:t>
+              <a:t>Live: garvitsurana271.github.io/pravaah   ·   Code: github.com/garvitsurana271/pravaah   ·   Garvit Surana &amp; team</a:t>
             </a:r>
           </a:p>
         </p:txBody>
@@ -3380,7 +3380,7 @@
                 </a:solidFill>
                 <a:latin typeface="Consolas"/>
               </a:rPr>
-              <a:t>HOW IT WORKS</a:t>
+              <a:t>HOW REAL IT IS</a:t>
             </a:r>
           </a:p>
         </p:txBody>
@@ -3419,7 +3419,7 @@
                 </a:solidFill>
                 <a:latin typeface="Segoe UI"/>
               </a:rPr>
-              <a:t>Two separated layers</a:t>
+              <a:t>Real stations, real trains, honest simulation</a:t>
             </a:r>
           </a:p>
         </p:txBody>
@@ -3452,13 +3452,13 @@
               </a:spcAft>
             </a:pPr>
             <a:r>
-              <a:rPr sz="1900" b="0">
+              <a:rPr sz="1800" b="0">
                 <a:solidFill>
                   <a:srgbClr val="22D37A"/>
                 </a:solidFill>
                 <a:latin typeface="Segoe UI"/>
               </a:rPr>
-              <a:t>INTERLOCKING (safety) — one train per block · single-line direction-lock · loop limits. Unsafe = impossible.</a:t>
+              <a:t>The national map is 8,697 real Indian stations with real coordinates, from the open datameet dataset.</a:t>
             </a:r>
           </a:p>
           <a:p>
@@ -3468,13 +3468,13 @@
               </a:spcAft>
             </a:pPr>
             <a:r>
-              <a:rPr sz="1900" b="0">
-                <a:solidFill>
-                  <a:srgbClr val="3AA0FF"/>
+              <a:rPr sz="1800" b="0">
+                <a:solidFill>
+                  <a:srgbClr val="E9F0FA"/>
                 </a:solidFill>
                 <a:latin typeface="Segoe UI"/>
               </a:rPr>
-              <a:t>DISPATCHER (policy) — OPTIMIZER vs FCFS; minimises weighted delay; emits a decision trace.</a:t>
+              <a:t>The trains are real services that run this corridor, pulled from the open timetable.</a:t>
             </a:r>
           </a:p>
           <a:p>
@@ -3484,13 +3484,13 @@
               </a:spcAft>
             </a:pPr>
             <a:r>
-              <a:rPr sz="1900" b="0">
-                <a:solidFill>
-                  <a:srgbClr val="E9F0FA"/>
+              <a:rPr sz="1800" b="0">
+                <a:solidFill>
+                  <a:srgbClr val="9AB0CF"/>
                 </a:solidFill>
                 <a:latin typeface="Segoe UI"/>
               </a:rPr>
-              <a:t>GLASS-BOX ENGINE — turns that trace into plain language + answers questions.</a:t>
+              <a:t>Live movement is simulated. India has no open real-time feed, so nobody can do live positions without faking them.</a:t>
             </a:r>
           </a:p>
           <a:p>
@@ -3500,13 +3500,13 @@
               </a:spcAft>
             </a:pPr>
             <a:r>
-              <a:rPr sz="1900" b="0">
+              <a:rPr sz="1800" b="0">
                 <a:solidFill>
                   <a:srgbClr val="9AB0CF"/>
                 </a:solidFill>
                 <a:latin typeface="Segoe UI"/>
               </a:rPr>
-              <a:t>Deterministic, tick-based, pure TypeScript. 100% client-side — no backend, no API keys.</a:t>
+              <a:t>The engine is built to sit on a real feed the day a railway grants access.</a:t>
             </a:r>
           </a:p>
         </p:txBody>
@@ -3552,7 +3552,7 @@
             <a:avLst/>
           </a:prstGeom>
           <a:solidFill>
-            <a:srgbClr val="22D37A"/>
+            <a:srgbClr val="3AA0FF"/>
           </a:solidFill>
           <a:ln>
             <a:noFill/>
@@ -3614,7 +3614,7 @@
                 </a:solidFill>
                 <a:latin typeface="Consolas"/>
               </a:rPr>
-              <a:t>VALIDATED DEMAND</a:t>
+              <a:t>HOW IT WORKS</a:t>
             </a:r>
           </a:p>
         </p:txBody>
@@ -3653,7 +3653,7 @@
                 </a:solidFill>
                 <a:latin typeface="Segoe UI"/>
               </a:rPr>
-              <a:t>We built the Ministry's own flagship problem</a:t>
+              <a:t>Two layers, kept separate</a:t>
             </a:r>
           </a:p>
         </p:txBody>
@@ -3686,45 +3686,61 @@
               </a:spcAft>
             </a:pPr>
             <a:r>
-              <a:rPr sz="2000" b="0">
+              <a:rPr sz="1800" b="0">
+                <a:solidFill>
+                  <a:srgbClr val="22D37A"/>
+                </a:solidFill>
+                <a:latin typeface="Segoe UI"/>
+              </a:rPr>
+              <a:t>Interlocking (safety): one train per block, single lines locked to one direction. Unsafe states are impossible here, in code.</a:t>
+            </a:r>
+          </a:p>
+          <a:p>
+            <a:pPr algn="l">
+              <a:spcAft>
+                <a:spcPts val="1400"/>
+              </a:spcAft>
+            </a:pPr>
+            <a:r>
+              <a:rPr sz="1800" b="0">
+                <a:solidFill>
+                  <a:srgbClr val="3AA0FF"/>
+                </a:solidFill>
+                <a:latin typeface="Segoe UI"/>
+              </a:rPr>
+              <a:t>Dispatcher (policy): the AI only picks the order among options that are already safe, and writes down a full trace.</a:t>
+            </a:r>
+          </a:p>
+          <a:p>
+            <a:pPr algn="l">
+              <a:spcAft>
+                <a:spcPts val="1400"/>
+              </a:spcAft>
+            </a:pPr>
+            <a:r>
+              <a:rPr sz="1800" b="0">
+                <a:solidFill>
+                  <a:srgbClr val="E9F0FA"/>
+                </a:solidFill>
+                <a:latin typeface="Segoe UI"/>
+              </a:rPr>
+              <a:t>Explanation engine: turns that trace into plain English, grounded in real numbers.</a:t>
+            </a:r>
+          </a:p>
+          <a:p>
+            <a:pPr algn="l">
+              <a:spcAft>
+                <a:spcPts val="1400"/>
+              </a:spcAft>
+            </a:pPr>
+            <a:r>
+              <a:rPr sz="1800" b="0">
                 <a:solidFill>
                   <a:srgbClr val="9AB0CF"/>
                 </a:solidFill>
                 <a:latin typeface="Segoe UI"/>
               </a:rPr>
-              <a:t>SIH25022 (Smart India Hackathon, Ministry of Railways):</a:t>
-            </a:r>
-          </a:p>
-          <a:p>
-            <a:pPr algn="l">
-              <a:spcAft>
-                <a:spcPts val="1400"/>
-              </a:spcAft>
-            </a:pPr>
-            <a:r>
-              <a:rPr sz="2000" b="0">
-                <a:solidFill>
-                  <a:srgbClr val="22D37A"/>
-                </a:solidFill>
-                <a:latin typeface="Segoe UI"/>
-              </a:rPr>
-              <a:t>“Maximizing section throughput through AI-powered, real-time train traffic control.”</a:t>
-            </a:r>
-          </a:p>
-          <a:p>
-            <a:pPr algn="l">
-              <a:spcAft>
-                <a:spcPts val="1400"/>
-              </a:spcAft>
-            </a:pPr>
-            <a:r>
-              <a:rPr sz="2000" b="0">
-                <a:solidFill>
-                  <a:srgbClr val="E9F0FA"/>
-                </a:solidFill>
-                <a:latin typeface="Segoe UI"/>
-              </a:rPr>
-              <a:t>Complementary to Kavach: Kavach is the safety-certified anti-collision floor; Pravaah is the throughput-and-explainability layer above it.</a:t>
+              <a:t>Pure TypeScript, 100% in the browser, no backend, no API keys, 12 passing tests.</a:t>
             </a:r>
           </a:p>
         </p:txBody>
@@ -3770,7 +3786,7 @@
             <a:avLst/>
           </a:prstGeom>
           <a:solidFill>
-            <a:srgbClr val="3AA0FF"/>
+            <a:srgbClr val="22D37A"/>
           </a:solidFill>
           <a:ln>
             <a:noFill/>
@@ -3832,7 +3848,7 @@
                 </a:solidFill>
                 <a:latin typeface="Consolas"/>
               </a:rPr>
-              <a:t>ENGINEERING</a:t>
+              <a:t>IT ANSWERS A REAL ASK</a:t>
             </a:r>
           </a:p>
         </p:txBody>
@@ -3871,7 +3887,7 @@
                 </a:solidFill>
                 <a:latin typeface="Segoe UI"/>
               </a:rPr>
-              <a:t>Built to be inspected</a:t>
+              <a:t>The Ministry's own problem statement</a:t>
             </a:r>
           </a:p>
         </p:txBody>
@@ -3906,11 +3922,27 @@
             <a:r>
               <a:rPr sz="1900" b="0">
                 <a:solidFill>
+                  <a:srgbClr val="22D37A"/>
+                </a:solidFill>
+                <a:latin typeface="Segoe UI"/>
+              </a:rPr>
+              <a:t>SIH25022, Ministry of Railways: "Maximizing section throughput through AI-powered, real-time train traffic control."</a:t>
+            </a:r>
+          </a:p>
+          <a:p>
+            <a:pPr algn="l">
+              <a:spcAft>
+                <a:spcPts val="1400"/>
+              </a:spcAft>
+            </a:pPr>
+            <a:r>
+              <a:rPr sz="1900" b="0">
+                <a:solidFill>
                   <a:srgbClr val="E9F0FA"/>
                 </a:solidFill>
                 <a:latin typeface="Segoe UI"/>
               </a:rPr>
-              <a:t>React 18 + TypeScript + Vite + Tailwind + SVG. Bundled fonts → fully offline.</a:t>
+              <a:t>It sits alongside Kavach, not against it. Kavach is the safety-certified anti-collision layer. Pravaah is the throughput and explainability layer above it.</a:t>
             </a:r>
           </a:p>
           <a:p>
@@ -3922,71 +3954,15 @@
             <a:r>
               <a:rPr sz="1900" b="0">
                 <a:solidFill>
-                  <a:srgbClr val="22D37A"/>
+                  <a:srgbClr val="9AB0CF"/>
                 </a:solidFill>
                 <a:latin typeface="Segoe UI"/>
               </a:rPr>
-              <a:t>12 passing tests: safety invariants, deadlock-freedom, optimizer-beats-FCFS, the safety refusal.</a:t>
-            </a:r>
-          </a:p>
-          <a:p>
-            <a:pPr algn="l">
-              <a:spcAft>
-                <a:spcPts val="1400"/>
-              </a:spcAft>
-            </a:pPr>
-            <a:r>
-              <a:rPr sz="1900" b="0">
-                <a:solidFill>
-                  <a:srgbClr val="9AB0CF"/>
-                </a:solidFill>
-                <a:latin typeface="Segoe UI"/>
-              </a:rPr>
-              <a:t>Real Indian station names &amp; coordinates from the open datameet/railways dataset (CC0).</a:t>
-            </a:r>
-          </a:p>
-          <a:p>
-            <a:pPr algn="l">
-              <a:spcAft>
-                <a:spcPts val="1400"/>
-              </a:spcAft>
-            </a:pPr>
-            <a:r>
-              <a:rPr sz="1900" b="0">
-                <a:solidFill>
-                  <a:srgbClr val="9AB0CF"/>
-                </a:solidFill>
-                <a:latin typeface="Segoe UI"/>
-              </a:rPr>
-              <a:t>One command to run: npm install &amp;&amp; npm run dev.</a:t>
-            </a:r>
-          </a:p>
-        </p:txBody>
-      </p:sp>
-      <p:pic>
-        <p:nvPicPr>
-          <p:cNvPr id="6" name="Picture 5" descr="disruption.png"/>
-          <p:cNvPicPr>
-            <a:picLocks noChangeAspect="1"/>
-          </p:cNvPicPr>
-          <p:nvPr/>
-        </p:nvPicPr>
-        <p:blipFill>
-          <a:blip r:embed="rId2"/>
-          <a:stretch>
-            <a:fillRect/>
-          </a:stretch>
-        </p:blipFill>
-        <p:spPr>
-          <a:xfrm>
-            <a:off x="6766560" y="4023360"/>
-            <a:ext cx="4937760" cy="2070126"/>
-          </a:xfrm>
-          <a:prstGeom prst="rect">
-            <a:avLst/>
-          </a:prstGeom>
-        </p:spPr>
-      </p:pic>
+              <a:t>It is a prototype and a decision-support concept, not certified train control. We say so plainly.</a:t>
+            </a:r>
+          </a:p>
+        </p:txBody>
+      </p:sp>
     </p:spTree>
   </p:cSld>
   <p:clrMapOvr>
@@ -4106,7 +4082,7 @@
                 </a:solidFill>
                 <a:latin typeface="Segoe UI"/>
               </a:rPr>
-              <a:t>Open. Explainable. Safe by construction. The control-room brain Indian Railways doesn't have yet.</a:t>
+              <a:t>Open. Explainable. Safe by design. The control-room brain Indian Railways does not have yet.</a:t>
             </a:r>
           </a:p>
           <a:p>
@@ -4122,7 +4098,7 @@
                 </a:solidFill>
                 <a:latin typeface="Segoe UI"/>
               </a:rPr>
-              <a:t>Honest scope: a decision-support prototype — complementary to, not a replacement for, India's safety-certified train control.</a:t>
+              <a:t>Try it live, then read the code. Both links below.</a:t>
             </a:r>
           </a:p>
         </p:txBody>
@@ -4161,7 +4137,7 @@
                 </a:solidFill>
                 <a:latin typeface="Consolas"/>
               </a:rPr>
-              <a:t>github.com/garvitsurana271/pravaah   ·   FAR AWAY 2026   ·   Railways   ·   SIH25022</a:t>
+              <a:t>garvitsurana271.github.io/pravaah   ·   github.com/garvitsurana271/pravaah   ·   FAR AWAY 2026</a:t>
             </a:r>
           </a:p>
         </p:txBody>
@@ -4269,7 +4245,7 @@
                 </a:solidFill>
                 <a:latin typeface="Consolas"/>
               </a:rPr>
-              <a:t>THE PROBLEM · PART 1</a:t>
+              <a:t>THE PROBLEM, PART 1</a:t>
             </a:r>
           </a:p>
         </p:txBody>
@@ -4308,7 +4284,7 @@
                 </a:solidFill>
                 <a:latin typeface="Segoe UI"/>
               </a:rPr>
-              <a:t>The next Balasore shouldn't depend on one tired controller's memory</a:t>
+              <a:t>A signalling failure put two trains on one track</a:t>
             </a:r>
           </a:p>
         </p:txBody>
@@ -4347,7 +4323,7 @@
                 </a:solidFill>
                 <a:latin typeface="Segoe UI"/>
               </a:rPr>
-              <a:t>2 June 2023 — a single mis-wired signalling circuit sent the Coromandel Express onto an occupied loop line at 128 km/h near Bahanaga Bazar, Balasore.</a:t>
+              <a:t>2 June 2023. A wrongly-wired circuit sent the Coromandel Express onto an occupied loop line at 128 km/h near Bahanaga Bazar, Balasore.</a:t>
             </a:r>
           </a:p>
           <a:p>
@@ -4363,7 +4339,7 @@
                 </a:solidFill>
                 <a:latin typeface="Segoe UI"/>
               </a:rPr>
-              <a:t>~300 dead. The line had no Kavach.</a:t>
+              <a:t>Close to 300 people died. The line had no Kavach.</a:t>
             </a:r>
           </a:p>
           <a:p>
@@ -4379,7 +4355,7 @@
                 </a:solidFill>
                 <a:latin typeface="Segoe UI"/>
               </a:rPr>
-              <a:t>June 2024 — a goods train ran a red signal (SPAD) and killed ten more on the Kanchanjunga Express. Again, no Kavach.</a:t>
+              <a:t>A year later a goods train ran a red signal and killed ten more on the Kanchanjunga Express. Again, no Kavach.</a:t>
             </a:r>
           </a:p>
         </p:txBody>
@@ -4487,7 +4463,7 @@
                 </a:solidFill>
                 <a:latin typeface="Consolas"/>
               </a:rPr>
-              <a:t>THE PROBLEM · PART 2</a:t>
+              <a:t>THE PROBLEM, PART 2</a:t>
             </a:r>
           </a:p>
         </p:txBody>
@@ -4526,7 +4502,7 @@
                 </a:solidFill>
                 <a:latin typeface="Segoe UI"/>
               </a:rPr>
-              <a:t>Indian Railways dispatches every train by hand</a:t>
+              <a:t>Indian Railways still dispatches by hand</a:t>
             </a:r>
           </a:p>
         </p:txBody>
@@ -4565,7 +4541,7 @@
                 </a:solidFill>
                 <a:latin typeface="Segoe UI"/>
               </a:rPr>
-              <a:t>A human section controller decides every crossing and precedence call from experience.</a:t>
+              <a:t>A human section controller decides every crossing and every precedence call from experience.</a:t>
             </a:r>
           </a:p>
           <a:p>
@@ -4581,7 +4557,7 @@
                 </a:solidFill>
                 <a:latin typeface="Segoe UI"/>
               </a:rPr>
-              <a:t>Control-room software (COA, ICMS, NTES) charts and monitors — it does not optimise.</a:t>
+              <a:t>The control-room software draws charts and shows where trains are. It does not make the decision.</a:t>
             </a:r>
           </a:p>
           <a:p>
@@ -4597,7 +4573,7 @@
                 </a:solidFill>
                 <a:latin typeface="Segoe UI"/>
               </a:rPr>
-              <a:t>Punctuality fell 94% (FY20-21) → 73.6% (FY23-24).</a:t>
+              <a:t>Punctuality fell from 94% to about 74% in three years.</a:t>
             </a:r>
           </a:p>
           <a:p>
@@ -4613,7 +4589,7 @@
                 </a:solidFill>
                 <a:latin typeface="Segoe UI"/>
               </a:rPr>
-              <a:t>Over 80% of the busiest corridors run above capacity.</a:t>
+              <a:t>Most of the busiest corridors now run above their rated capacity.</a:t>
             </a:r>
           </a:p>
         </p:txBody>
@@ -4721,7 +4697,7 @@
                 </a:solidFill>
                 <a:latin typeface="Consolas"/>
               </a:rPr>
-              <a:t>THE GAP = OUR NOVELTY</a:t>
+              <a:t>THE GAP WE FILL</a:t>
             </a:r>
           </a:p>
         </p:txBody>
@@ -4760,7 +4736,7 @@
                 </a:solidFill>
                 <a:latin typeface="Segoe UI"/>
               </a:rPr>
-              <a:t>Proprietary ₹1000-crore black boxes — or nothing</a:t>
+              <a:t>Closed systems that cost crores, or nothing at all</a:t>
             </a:r>
           </a:p>
         </p:txBody>
@@ -4793,13 +4769,13 @@
               </a:spcAft>
             </a:pPr>
             <a:r>
-              <a:rPr sz="1900" b="0">
+              <a:rPr sz="1800" b="0">
                 <a:solidFill>
                   <a:srgbClr val="E9F0FA"/>
                 </a:solidFill>
                 <a:latin typeface="Segoe UI"/>
               </a:rPr>
-              <a:t>Hitachi / Siemens / Alstom sell closed, crore-scale traffic-management systems — and even those stay advisory, because controllers don't trust black boxes.</a:t>
+              <a:t>Hitachi, Siemens and Alstom sell AI traffic management as closed systems above a thousand crore, and even those stay advisory because controllers do not trust a black box.</a:t>
             </a:r>
           </a:p>
           <a:p>
@@ -4809,13 +4785,13 @@
               </a:spcAft>
             </a:pPr>
             <a:r>
-              <a:rPr sz="1900" b="0">
+              <a:rPr sz="1800" b="0">
                 <a:solidFill>
                   <a:srgbClr val="22D37A"/>
                 </a:solidFill>
                 <a:latin typeface="Segoe UI"/>
               </a:rPr>
-              <a:t>There is NO open, India-specific, explainable tool for this.</a:t>
+              <a:t>There is no open, India-specific, explainable tool for this.</a:t>
             </a:r>
           </a:p>
           <a:p>
@@ -4825,13 +4801,13 @@
               </a:spcAft>
             </a:pPr>
             <a:r>
-              <a:rPr sz="1900" b="0">
+              <a:rPr sz="1800" b="0">
                 <a:solidFill>
                   <a:srgbClr val="9AB0CF"/>
                 </a:solidFill>
                 <a:latin typeface="Segoe UI"/>
               </a:rPr>
-              <a:t>Pravaah's novelty is the stack: open + explainable + India + real-time recovery — not the underlying operations-research.</a:t>
+              <a:t>Our contribution is the combination, not the math: open, explainable, India-specific, with safety as a hard floor.</a:t>
             </a:r>
           </a:p>
           <a:p>
@@ -4841,13 +4817,13 @@
               </a:spcAft>
             </a:pPr>
             <a:r>
-              <a:rPr sz="1900" b="0">
+              <a:rPr sz="1800" b="0">
                 <a:solidFill>
                   <a:srgbClr val="9AB0CF"/>
                 </a:solidFill>
                 <a:latin typeface="Segoe UI"/>
               </a:rPr>
-              <a:t>We deliberately avoided RL-for-dispatching: the Flatland challenge showed classical OR beats it, and it has never deployed.</a:t>
+              <a:t>We did not use reinforcement learning on purpose. The evidence (the Flatland challenge) shows classical optimization beats it and RL has never been deployed.</a:t>
             </a:r>
           </a:p>
         </p:txBody>
@@ -4994,7 +4970,7 @@
                 </a:solidFill>
                 <a:latin typeface="Segoe UI"/>
               </a:rPr>
-              <a:t>A live control room for one congested section</a:t>
+              <a:t>A live control room for one busy section</a:t>
             </a:r>
           </a:p>
         </p:txBody>
@@ -5057,7 +5033,7 @@
                 </a:solidFill>
                 <a:latin typeface="Consolas"/>
               </a:rPr>
-              <a:t>Two brains run side-by-side on the same scenario: the AI optimizer and the manual first-come-first-served baseline.</a:t>
+              <a:t>Two dispatchers run on the same trains: the AI optimizer, and first-come-first-served, which is how it is done today.</a:t>
             </a:r>
           </a:p>
         </p:txBody>
@@ -5165,7 +5141,7 @@
                 </a:solidFill>
                 <a:latin typeface="Consolas"/>
               </a:rPr>
-              <a:t>RESULT · THROUGHPUT</a:t>
+              <a:t>THE RESULT</a:t>
             </a:r>
           </a:p>
         </p:txBody>
@@ -5204,7 +5180,7 @@
                 </a:solidFill>
                 <a:latin typeface="Segoe UI"/>
               </a:rPr>
-              <a:t>Flip the optimizer off — watch the delay jump</a:t>
+              <a:t>Switch the AI off and the delay climbs</a:t>
             </a:r>
           </a:p>
         </p:txBody>
@@ -5243,7 +5219,7 @@
                 </a:solidFill>
                 <a:latin typeface="Segoe UI"/>
               </a:rPr>
-              <a:t>Same eight trains, same track. The optimizer minimises Σ (delay × priority-weight).</a:t>
+              <a:t>Same trains, same track. The optimizer keeps total delay down by setting smart precedence at each crossing.</a:t>
             </a:r>
           </a:p>
           <a:p>
@@ -5259,7 +5235,7 @@
                 </a:solidFill>
                 <a:latin typeface="Segoe UI"/>
               </a:rPr>
-              <a:t>–20% weighted delay vs. the manual FCFS baseline.</a:t>
+              <a:t>About 20% less delay than the manual first-come-first-served baseline.</a:t>
             </a:r>
           </a:p>
           <a:p>
@@ -5275,7 +5251,7 @@
                 </a:solidFill>
                 <a:latin typeface="Segoe UI"/>
               </a:rPr>
-              <a:t>It doesn't move more trains — it protects the premier ones, spending a goods rake's minutes to save a Superfast's.</a:t>
+              <a:t>It does not move more trains. It protects the important ones, spending a goods train's minutes to save a Superfast's.</a:t>
             </a:r>
           </a:p>
           <a:p>
@@ -5291,7 +5267,7 @@
                 </a:solidFill>
                 <a:latin typeface="Segoe UI"/>
               </a:rPr>
-              <a:t>13 conflicts auto-resolved. 0 unsafe states. (measured by the test suite)</a:t>
+              <a:t>13 conflicts resolved automatically, zero unsafe states. Measured by the test suite.</a:t>
             </a:r>
           </a:p>
         </p:txBody>
@@ -5399,7 +5375,7 @@
                 </a:solidFill>
                 <a:latin typeface="Consolas"/>
               </a:rPr>
-              <a:t>THE DIFFERENTIATOR</a:t>
+              <a:t>WHAT MAKES IT DIFFERENT</a:t>
             </a:r>
           </a:p>
         </p:txBody>
@@ -5438,7 +5414,7 @@
                 </a:solidFill>
                 <a:latin typeface="Segoe UI"/>
               </a:rPr>
-              <a:t>It explains every call — in plain language</a:t>
+              <a:t>It explains every call in plain words</a:t>
             </a:r>
           </a:p>
         </p:txBody>
@@ -5477,7 +5453,7 @@
                 </a:solidFill>
                 <a:latin typeface="Segoe UI"/>
               </a:rPr>
-              <a:t>Every decision is the solver's own trace, rendered as auditable reasoning — never invented.</a:t>
+              <a:t>Every decision is the optimizer's own working, written out. Nothing is invented.</a:t>
             </a:r>
           </a:p>
           <a:p>
@@ -5493,7 +5469,7 @@
                 </a:solidFill>
                 <a:latin typeface="Segoe UI"/>
               </a:rPr>
-              <a:t>“Held 18045 (Express, ×3) so the Superfast could cross — reversing would cost 1.7× more.”</a:t>
+              <a:t>"Held the Express 11 min so the Superfast could cross. Reversing it would cost 1.7 times more."</a:t>
             </a:r>
           </a:p>
           <a:p>
@@ -5509,7 +5485,7 @@
                 </a:solidFill>
                 <a:latin typeface="Segoe UI"/>
               </a:rPr>
-              <a:t>This directly answers why AI dispatching isn't adopted: black-box distrust.</a:t>
+              <a:t>This answers why AI dispatching is not adopted today: controllers do not trust black boxes.</a:t>
             </a:r>
           </a:p>
         </p:txBody>
@@ -5641,7 +5617,7 @@
                 </a:solidFill>
                 <a:latin typeface="Consolas"/>
               </a:rPr>
-              <a:t>INTERROGATE IT</a:t>
+              <a:t>YOU CAN QUESTION IT</a:t>
             </a:r>
           </a:p>
         </p:txBody>
@@ -5680,7 +5656,7 @@
                 </a:solidFill>
                 <a:latin typeface="Segoe UI"/>
               </a:rPr>
-              <a:t>Ask the dispatcher anything — offline</a:t>
+              <a:t>Ask the dispatcher anything, offline</a:t>
             </a:r>
           </a:p>
         </p:txBody>
@@ -5719,7 +5695,7 @@
                 </a:solidFill>
                 <a:latin typeface="Segoe UI"/>
               </a:rPr>
-              <a:t>“Why is 12841 held?”  “Is the section safe?”  “What's the cost of overriding?”</a:t>
+              <a:t>"Why is 12801 held?"  "Is the section safe?"  "What would an override cost?"</a:t>
             </a:r>
           </a:p>
           <a:p>
@@ -5735,7 +5711,7 @@
                 </a:solidFill>
                 <a:latin typeface="Segoe UI"/>
               </a:rPr>
-              <a:t>Grounded in the same decision trace. No network call — the demo cannot break.</a:t>
+              <a:t>Answers come from the same decision trace. No network call, so the demo cannot break.</a:t>
             </a:r>
           </a:p>
           <a:p>
@@ -5751,7 +5727,7 @@
                 </a:solidFill>
                 <a:latin typeface="Segoe UI"/>
               </a:rPr>
-              <a:t>The controller stays in command; the machine just shows the cost of each choice.</a:t>
+              <a:t>The controller stays in charge. The machine just shows the cost of each choice.</a:t>
             </a:r>
           </a:p>
         </p:txBody>
@@ -5922,7 +5898,7 @@
                 </a:solidFill>
                 <a:latin typeface="Segoe UI"/>
               </a:rPr>
-              <a:t>Unsafe states are impossible by construction</a:t>
+              <a:t>It cannot cause a collision, by design</a:t>
             </a:r>
           </a:p>
         </p:txBody>
@@ -5961,7 +5937,7 @@
                 </a:solidFill>
                 <a:latin typeface="Segoe UI"/>
               </a:rPr>
-              <a:t>A separate interlocking layer enforces one-train-per-block and single-line direction-locks — independent of any AI policy.</a:t>
+              <a:t>A separate interlocking layer enforces one train per block and locks single lines to one direction, no matter what the AI does.</a:t>
             </a:r>
           </a:p>
           <a:p>
@@ -5977,7 +5953,7 @@
                 </a:solidFill>
                 <a:latin typeface="Segoe UI"/>
               </a:rPr>
-              <a:t>Re-stage the Balasore failure: a route mis-set toward an occupied line is REFUSED.</a:t>
+              <a:t>Re-stage the Balasore failure: a route set toward an occupied line is refused.</a:t>
             </a:r>
           </a:p>
           <a:p>
@@ -5993,7 +5969,7 @@
                 </a:solidFill>
                 <a:latin typeface="Segoe UI"/>
               </a:rPr>
-              <a:t>Safety is a hard invariant; the AI only optimises within the safe envelope.</a:t>
+              <a:t>Safety is a hard floor. The AI only optimizes inside what is already safe.</a:t>
             </a:r>
           </a:p>
         </p:txBody>

</xml_diff>

<commit_message>
Rebuild deck: full-bleed product shots, giant numbers, 9 tight slides; new UI screenshots
</commit_message>
<xml_diff>
--- a/Pravaah-Deck.pptx
+++ b/Pravaah-Deck.pptx
@@ -14,10 +14,6 @@
     <p:sldId id="262" r:id="rId13"/>
     <p:sldId id="263" r:id="rId14"/>
     <p:sldId id="264" r:id="rId15"/>
-    <p:sldId id="265" r:id="rId16"/>
-    <p:sldId id="266" r:id="rId17"/>
-    <p:sldId id="267" r:id="rId18"/>
-    <p:sldId id="268" r:id="rId19"/>
   </p:sldIdLst>
   <p:sldSz cx="12191695" cy="6858000" type="screen4x3"/>
   <p:notesSz cx="6858000" cy="9144000"/>
@@ -3110,57 +3106,14 @@
       <p:grpSpPr/>
       <p:sp>
         <p:nvSpPr>
-          <p:cNvPr id="2" name="Rectangle 1"/>
-          <p:cNvSpPr/>
-          <p:nvPr/>
-        </p:nvSpPr>
-        <p:spPr>
-          <a:xfrm>
-            <a:off x="0" y="0"/>
-            <a:ext cx="128016" cy="6858000"/>
-          </a:xfrm>
-          <a:prstGeom prst="rect">
-            <a:avLst/>
-          </a:prstGeom>
-          <a:solidFill>
-            <a:srgbClr val="22D37A"/>
-          </a:solidFill>
-          <a:ln>
-            <a:noFill/>
-          </a:ln>
-        </p:spPr>
-        <p:style>
-          <a:lnRef idx="1">
-            <a:schemeClr val="accent1"/>
-          </a:lnRef>
-          <a:fillRef idx="3">
-            <a:schemeClr val="accent1"/>
-          </a:fillRef>
-          <a:effectRef idx="2">
-            <a:schemeClr val="accent1"/>
-          </a:effectRef>
-          <a:fontRef idx="minor">
-            <a:schemeClr val="lt1"/>
-          </a:fontRef>
-        </p:style>
-        <p:txBody>
-          <a:bodyPr rtlCol="0" anchor="ctr"/>
-          <a:lstStyle/>
-          <a:p>
-            <a:pPr algn="ctr"/>
-          </a:p>
-        </p:txBody>
-      </p:sp>
-      <p:sp>
-        <p:nvSpPr>
-          <p:cNvPr id="3" name="TextBox 2"/>
+          <p:cNvPr id="2" name="TextBox 1"/>
           <p:cNvSpPr txBox="1"/>
           <p:nvPr/>
         </p:nvSpPr>
         <p:spPr>
           <a:xfrm>
-            <a:off x="822960" y="1920240"/>
-            <a:ext cx="10515600" cy="2926080"/>
+            <a:off x="822960" y="2194560"/>
+            <a:ext cx="10515600" cy="2743200"/>
           </a:xfrm>
           <a:prstGeom prst="rect">
             <a:avLst/>
@@ -3179,7 +3132,7 @@
               </a:spcAft>
             </a:pPr>
             <a:r>
-              <a:rPr sz="1500" b="1">
+              <a:rPr sz="1400" b="1">
                 <a:solidFill>
                   <a:srgbClr val="3AA0FF"/>
                 </a:solidFill>
@@ -3191,31 +3144,31 @@
           <a:p>
             <a:pPr algn="l">
               <a:spcAft>
-                <a:spcPts val="400"/>
+                <a:spcPts val="200"/>
               </a:spcAft>
             </a:pPr>
             <a:r>
-              <a:rPr sz="6000" b="1">
-                <a:solidFill>
-                  <a:srgbClr val="E9F0FA"/>
-                </a:solidFill>
-                <a:latin typeface="Segoe UI"/>
+              <a:rPr sz="6600" b="1">
+                <a:solidFill>
+                  <a:srgbClr val="ECF2FB"/>
+                </a:solidFill>
+                <a:latin typeface="Segoe UI Semibold"/>
               </a:rPr>
-              <a:t>PRAVAAH  प्रवाह</a:t>
+              <a:t>PRAVAAH</a:t>
             </a:r>
           </a:p>
           <a:p>
             <a:pPr algn="l">
               <a:spcAft>
-                <a:spcPts val="1600"/>
+                <a:spcPts val="1400"/>
               </a:spcAft>
             </a:pPr>
             <a:r>
-              <a:rPr sz="3000" b="1">
+              <a:rPr sz="2800" b="1">
                 <a:solidFill>
                   <a:srgbClr val="22D37A"/>
                 </a:solidFill>
-                <a:latin typeface="Segoe UI"/>
+                <a:latin typeface="Segoe UI Semibold"/>
               </a:rPr>
               <a:t>The Glass-Box Dispatcher</a:t>
             </a:r>
@@ -3227,26 +3180,26 @@
               </a:spcAft>
             </a:pPr>
             <a:r>
-              <a:rPr sz="1900" b="0">
+              <a:rPr sz="1800" b="0">
                 <a:solidFill>
                   <a:srgbClr val="9AB0CF"/>
                 </a:solidFill>
-                <a:latin typeface="Segoe UI"/>
+                <a:latin typeface="Segoe UI Semibold"/>
               </a:rPr>
-              <a:t>An open, explainable AI co-pilot for the Indian Railways section controller.</a:t>
-            </a:r>
-          </a:p>
-        </p:txBody>
-      </p:sp>
-      <p:sp>
-        <p:nvSpPr>
-          <p:cNvPr id="4" name="TextBox 3"/>
+              <a:t>An open, explainable AI co-pilot for the Indian Railways section controller. Live and working.</a:t>
+            </a:r>
+          </a:p>
+        </p:txBody>
+      </p:sp>
+      <p:sp>
+        <p:nvSpPr>
+          <p:cNvPr id="3" name="TextBox 2"/>
           <p:cNvSpPr txBox="1"/>
           <p:nvPr/>
         </p:nvSpPr>
         <p:spPr>
           <a:xfrm>
-            <a:off x="640080" y="6400800"/>
+            <a:off x="640080" y="6419088"/>
             <a:ext cx="10972800" cy="365760"/>
           </a:xfrm>
           <a:prstGeom prst="rect">
@@ -3266,878 +3219,13 @@
               </a:spcAft>
             </a:pPr>
             <a:r>
-              <a:rPr sz="1100" b="0">
+              <a:rPr sz="1050" b="0">
                 <a:solidFill>
                   <a:srgbClr val="9AB0CF"/>
                 </a:solidFill>
                 <a:latin typeface="Consolas"/>
               </a:rPr>
-              <a:t>Live: garvitsurana271.github.io/pravaah   ·   Code: github.com/garvitsurana271/pravaah   ·   Garvit Surana &amp; team</a:t>
-            </a:r>
-          </a:p>
-        </p:txBody>
-      </p:sp>
-    </p:spTree>
-  </p:cSld>
-  <p:clrMapOvr>
-    <a:masterClrMapping/>
-  </p:clrMapOvr>
-</p:sld>
-</file>
-
-<file path=ppt/slides/slide10.xml><?xml version="1.0" encoding="utf-8"?>
-<p:sld xmlns:a="http://schemas.openxmlformats.org/drawingml/2006/main" xmlns:p="http://schemas.openxmlformats.org/presentationml/2006/main" xmlns:r="http://schemas.openxmlformats.org/officeDocument/2006/relationships">
-  <p:cSld>
-    <p:bg>
-      <p:bgPr>
-        <a:solidFill>
-          <a:srgbClr val="020617"/>
-        </a:solidFill>
-        <a:effectLst/>
-      </p:bgPr>
-    </p:bg>
-    <p:spTree>
-      <p:nvGrpSpPr>
-        <p:cNvPr id="1" name=""/>
-        <p:cNvGrpSpPr/>
-        <p:nvPr/>
-      </p:nvGrpSpPr>
-      <p:grpSpPr/>
-      <p:sp>
-        <p:nvSpPr>
-          <p:cNvPr id="2" name="Rectangle 1"/>
-          <p:cNvSpPr/>
-          <p:nvPr/>
-        </p:nvSpPr>
-        <p:spPr>
-          <a:xfrm>
-            <a:off x="0" y="0"/>
-            <a:ext cx="128016" cy="6858000"/>
-          </a:xfrm>
-          <a:prstGeom prst="rect">
-            <a:avLst/>
-          </a:prstGeom>
-          <a:solidFill>
-            <a:srgbClr val="3AA0FF"/>
-          </a:solidFill>
-          <a:ln>
-            <a:noFill/>
-          </a:ln>
-        </p:spPr>
-        <p:style>
-          <a:lnRef idx="1">
-            <a:schemeClr val="accent1"/>
-          </a:lnRef>
-          <a:fillRef idx="3">
-            <a:schemeClr val="accent1"/>
-          </a:fillRef>
-          <a:effectRef idx="2">
-            <a:schemeClr val="accent1"/>
-          </a:effectRef>
-          <a:fontRef idx="minor">
-            <a:schemeClr val="lt1"/>
-          </a:fontRef>
-        </p:style>
-        <p:txBody>
-          <a:bodyPr rtlCol="0" anchor="ctr"/>
-          <a:lstStyle/>
-          <a:p>
-            <a:pPr algn="ctr"/>
-          </a:p>
-        </p:txBody>
-      </p:sp>
-      <p:sp>
-        <p:nvSpPr>
-          <p:cNvPr id="3" name="TextBox 2"/>
-          <p:cNvSpPr txBox="1"/>
-          <p:nvPr/>
-        </p:nvSpPr>
-        <p:spPr>
-          <a:xfrm>
-            <a:off x="640080" y="457200"/>
-            <a:ext cx="10972800" cy="457200"/>
-          </a:xfrm>
-          <a:prstGeom prst="rect">
-            <a:avLst/>
-          </a:prstGeom>
-          <a:noFill/>
-        </p:spPr>
-        <p:txBody>
-          <a:bodyPr wrap="square" anchor="t">
-            <a:spAutoFit/>
-          </a:bodyPr>
-          <a:lstStyle/>
-          <a:p>
-            <a:pPr algn="l">
-              <a:spcAft>
-                <a:spcPts val="800"/>
-              </a:spcAft>
-            </a:pPr>
-            <a:r>
-              <a:rPr sz="1300" b="1">
-                <a:solidFill>
-                  <a:srgbClr val="22D37A"/>
-                </a:solidFill>
-                <a:latin typeface="Consolas"/>
-              </a:rPr>
-              <a:t>HOW REAL IT IS</a:t>
-            </a:r>
-          </a:p>
-        </p:txBody>
-      </p:sp>
-      <p:sp>
-        <p:nvSpPr>
-          <p:cNvPr id="4" name="TextBox 3"/>
-          <p:cNvSpPr txBox="1"/>
-          <p:nvPr/>
-        </p:nvSpPr>
-        <p:spPr>
-          <a:xfrm>
-            <a:off x="640080" y="868680"/>
-            <a:ext cx="10972800" cy="1188720"/>
-          </a:xfrm>
-          <a:prstGeom prst="rect">
-            <a:avLst/>
-          </a:prstGeom>
-          <a:noFill/>
-        </p:spPr>
-        <p:txBody>
-          <a:bodyPr wrap="square" anchor="t">
-            <a:spAutoFit/>
-          </a:bodyPr>
-          <a:lstStyle/>
-          <a:p>
-            <a:pPr algn="l">
-              <a:spcAft>
-                <a:spcPts val="800"/>
-              </a:spcAft>
-            </a:pPr>
-            <a:r>
-              <a:rPr sz="4000" b="1">
-                <a:solidFill>
-                  <a:srgbClr val="E9F0FA"/>
-                </a:solidFill>
-                <a:latin typeface="Segoe UI"/>
-              </a:rPr>
-              <a:t>Real stations, real trains, honest simulation</a:t>
-            </a:r>
-          </a:p>
-        </p:txBody>
-      </p:sp>
-      <p:sp>
-        <p:nvSpPr>
-          <p:cNvPr id="5" name="TextBox 4"/>
-          <p:cNvSpPr txBox="1"/>
-          <p:nvPr/>
-        </p:nvSpPr>
-        <p:spPr>
-          <a:xfrm>
-            <a:off x="640080" y="2011680"/>
-            <a:ext cx="10515600" cy="4206240"/>
-          </a:xfrm>
-          <a:prstGeom prst="rect">
-            <a:avLst/>
-          </a:prstGeom>
-          <a:noFill/>
-        </p:spPr>
-        <p:txBody>
-          <a:bodyPr wrap="square" anchor="t">
-            <a:spAutoFit/>
-          </a:bodyPr>
-          <a:lstStyle/>
-          <a:p>
-            <a:pPr algn="l">
-              <a:spcAft>
-                <a:spcPts val="1400"/>
-              </a:spcAft>
-            </a:pPr>
-            <a:r>
-              <a:rPr sz="1800" b="0">
-                <a:solidFill>
-                  <a:srgbClr val="22D37A"/>
-                </a:solidFill>
-                <a:latin typeface="Segoe UI"/>
-              </a:rPr>
-              <a:t>The national map is 8,697 real Indian stations with real coordinates, from the open datameet dataset.</a:t>
-            </a:r>
-          </a:p>
-          <a:p>
-            <a:pPr algn="l">
-              <a:spcAft>
-                <a:spcPts val="1400"/>
-              </a:spcAft>
-            </a:pPr>
-            <a:r>
-              <a:rPr sz="1800" b="0">
-                <a:solidFill>
-                  <a:srgbClr val="E9F0FA"/>
-                </a:solidFill>
-                <a:latin typeface="Segoe UI"/>
-              </a:rPr>
-              <a:t>The trains are real services that run this corridor, pulled from the open timetable.</a:t>
-            </a:r>
-          </a:p>
-          <a:p>
-            <a:pPr algn="l">
-              <a:spcAft>
-                <a:spcPts val="1400"/>
-              </a:spcAft>
-            </a:pPr>
-            <a:r>
-              <a:rPr sz="1800" b="0">
-                <a:solidFill>
-                  <a:srgbClr val="9AB0CF"/>
-                </a:solidFill>
-                <a:latin typeface="Segoe UI"/>
-              </a:rPr>
-              <a:t>Live movement is simulated. India has no open real-time feed, so nobody can do live positions without faking them.</a:t>
-            </a:r>
-          </a:p>
-          <a:p>
-            <a:pPr algn="l">
-              <a:spcAft>
-                <a:spcPts val="1400"/>
-              </a:spcAft>
-            </a:pPr>
-            <a:r>
-              <a:rPr sz="1800" b="0">
-                <a:solidFill>
-                  <a:srgbClr val="9AB0CF"/>
-                </a:solidFill>
-                <a:latin typeface="Segoe UI"/>
-              </a:rPr>
-              <a:t>The engine is built to sit on a real feed the day a railway grants access.</a:t>
-            </a:r>
-          </a:p>
-        </p:txBody>
-      </p:sp>
-    </p:spTree>
-  </p:cSld>
-  <p:clrMapOvr>
-    <a:masterClrMapping/>
-  </p:clrMapOvr>
-</p:sld>
-</file>
-
-<file path=ppt/slides/slide11.xml><?xml version="1.0" encoding="utf-8"?>
-<p:sld xmlns:a="http://schemas.openxmlformats.org/drawingml/2006/main" xmlns:p="http://schemas.openxmlformats.org/presentationml/2006/main" xmlns:r="http://schemas.openxmlformats.org/officeDocument/2006/relationships">
-  <p:cSld>
-    <p:bg>
-      <p:bgPr>
-        <a:solidFill>
-          <a:srgbClr val="020617"/>
-        </a:solidFill>
-        <a:effectLst/>
-      </p:bgPr>
-    </p:bg>
-    <p:spTree>
-      <p:nvGrpSpPr>
-        <p:cNvPr id="1" name=""/>
-        <p:cNvGrpSpPr/>
-        <p:nvPr/>
-      </p:nvGrpSpPr>
-      <p:grpSpPr/>
-      <p:sp>
-        <p:nvSpPr>
-          <p:cNvPr id="2" name="Rectangle 1"/>
-          <p:cNvSpPr/>
-          <p:nvPr/>
-        </p:nvSpPr>
-        <p:spPr>
-          <a:xfrm>
-            <a:off x="0" y="0"/>
-            <a:ext cx="128016" cy="6858000"/>
-          </a:xfrm>
-          <a:prstGeom prst="rect">
-            <a:avLst/>
-          </a:prstGeom>
-          <a:solidFill>
-            <a:srgbClr val="3AA0FF"/>
-          </a:solidFill>
-          <a:ln>
-            <a:noFill/>
-          </a:ln>
-        </p:spPr>
-        <p:style>
-          <a:lnRef idx="1">
-            <a:schemeClr val="accent1"/>
-          </a:lnRef>
-          <a:fillRef idx="3">
-            <a:schemeClr val="accent1"/>
-          </a:fillRef>
-          <a:effectRef idx="2">
-            <a:schemeClr val="accent1"/>
-          </a:effectRef>
-          <a:fontRef idx="minor">
-            <a:schemeClr val="lt1"/>
-          </a:fontRef>
-        </p:style>
-        <p:txBody>
-          <a:bodyPr rtlCol="0" anchor="ctr"/>
-          <a:lstStyle/>
-          <a:p>
-            <a:pPr algn="ctr"/>
-          </a:p>
-        </p:txBody>
-      </p:sp>
-      <p:sp>
-        <p:nvSpPr>
-          <p:cNvPr id="3" name="TextBox 2"/>
-          <p:cNvSpPr txBox="1"/>
-          <p:nvPr/>
-        </p:nvSpPr>
-        <p:spPr>
-          <a:xfrm>
-            <a:off x="640080" y="457200"/>
-            <a:ext cx="10972800" cy="457200"/>
-          </a:xfrm>
-          <a:prstGeom prst="rect">
-            <a:avLst/>
-          </a:prstGeom>
-          <a:noFill/>
-        </p:spPr>
-        <p:txBody>
-          <a:bodyPr wrap="square" anchor="t">
-            <a:spAutoFit/>
-          </a:bodyPr>
-          <a:lstStyle/>
-          <a:p>
-            <a:pPr algn="l">
-              <a:spcAft>
-                <a:spcPts val="800"/>
-              </a:spcAft>
-            </a:pPr>
-            <a:r>
-              <a:rPr sz="1300" b="1">
-                <a:solidFill>
-                  <a:srgbClr val="22D37A"/>
-                </a:solidFill>
-                <a:latin typeface="Consolas"/>
-              </a:rPr>
-              <a:t>HOW IT WORKS</a:t>
-            </a:r>
-          </a:p>
-        </p:txBody>
-      </p:sp>
-      <p:sp>
-        <p:nvSpPr>
-          <p:cNvPr id="4" name="TextBox 3"/>
-          <p:cNvSpPr txBox="1"/>
-          <p:nvPr/>
-        </p:nvSpPr>
-        <p:spPr>
-          <a:xfrm>
-            <a:off x="640080" y="868680"/>
-            <a:ext cx="10972800" cy="1188720"/>
-          </a:xfrm>
-          <a:prstGeom prst="rect">
-            <a:avLst/>
-          </a:prstGeom>
-          <a:noFill/>
-        </p:spPr>
-        <p:txBody>
-          <a:bodyPr wrap="square" anchor="t">
-            <a:spAutoFit/>
-          </a:bodyPr>
-          <a:lstStyle/>
-          <a:p>
-            <a:pPr algn="l">
-              <a:spcAft>
-                <a:spcPts val="800"/>
-              </a:spcAft>
-            </a:pPr>
-            <a:r>
-              <a:rPr sz="4000" b="1">
-                <a:solidFill>
-                  <a:srgbClr val="E9F0FA"/>
-                </a:solidFill>
-                <a:latin typeface="Segoe UI"/>
-              </a:rPr>
-              <a:t>Two layers, kept separate</a:t>
-            </a:r>
-          </a:p>
-        </p:txBody>
-      </p:sp>
-      <p:sp>
-        <p:nvSpPr>
-          <p:cNvPr id="5" name="TextBox 4"/>
-          <p:cNvSpPr txBox="1"/>
-          <p:nvPr/>
-        </p:nvSpPr>
-        <p:spPr>
-          <a:xfrm>
-            <a:off x="640080" y="2011680"/>
-            <a:ext cx="10515600" cy="4206240"/>
-          </a:xfrm>
-          <a:prstGeom prst="rect">
-            <a:avLst/>
-          </a:prstGeom>
-          <a:noFill/>
-        </p:spPr>
-        <p:txBody>
-          <a:bodyPr wrap="square" anchor="t">
-            <a:spAutoFit/>
-          </a:bodyPr>
-          <a:lstStyle/>
-          <a:p>
-            <a:pPr algn="l">
-              <a:spcAft>
-                <a:spcPts val="1400"/>
-              </a:spcAft>
-            </a:pPr>
-            <a:r>
-              <a:rPr sz="1800" b="0">
-                <a:solidFill>
-                  <a:srgbClr val="22D37A"/>
-                </a:solidFill>
-                <a:latin typeface="Segoe UI"/>
-              </a:rPr>
-              <a:t>Interlocking (safety): one train per block, single lines locked to one direction. Unsafe states are impossible here, in code.</a:t>
-            </a:r>
-          </a:p>
-          <a:p>
-            <a:pPr algn="l">
-              <a:spcAft>
-                <a:spcPts val="1400"/>
-              </a:spcAft>
-            </a:pPr>
-            <a:r>
-              <a:rPr sz="1800" b="0">
-                <a:solidFill>
-                  <a:srgbClr val="3AA0FF"/>
-                </a:solidFill>
-                <a:latin typeface="Segoe UI"/>
-              </a:rPr>
-              <a:t>Dispatcher (policy): the AI only picks the order among options that are already safe, and writes down a full trace.</a:t>
-            </a:r>
-          </a:p>
-          <a:p>
-            <a:pPr algn="l">
-              <a:spcAft>
-                <a:spcPts val="1400"/>
-              </a:spcAft>
-            </a:pPr>
-            <a:r>
-              <a:rPr sz="1800" b="0">
-                <a:solidFill>
-                  <a:srgbClr val="E9F0FA"/>
-                </a:solidFill>
-                <a:latin typeface="Segoe UI"/>
-              </a:rPr>
-              <a:t>Explanation engine: turns that trace into plain English, grounded in real numbers.</a:t>
-            </a:r>
-          </a:p>
-          <a:p>
-            <a:pPr algn="l">
-              <a:spcAft>
-                <a:spcPts val="1400"/>
-              </a:spcAft>
-            </a:pPr>
-            <a:r>
-              <a:rPr sz="1800" b="0">
-                <a:solidFill>
-                  <a:srgbClr val="9AB0CF"/>
-                </a:solidFill>
-                <a:latin typeface="Segoe UI"/>
-              </a:rPr>
-              <a:t>Pure TypeScript, 100% in the browser, no backend, no API keys, 12 passing tests.</a:t>
-            </a:r>
-          </a:p>
-        </p:txBody>
-      </p:sp>
-    </p:spTree>
-  </p:cSld>
-  <p:clrMapOvr>
-    <a:masterClrMapping/>
-  </p:clrMapOvr>
-</p:sld>
-</file>
-
-<file path=ppt/slides/slide12.xml><?xml version="1.0" encoding="utf-8"?>
-<p:sld xmlns:a="http://schemas.openxmlformats.org/drawingml/2006/main" xmlns:p="http://schemas.openxmlformats.org/presentationml/2006/main" xmlns:r="http://schemas.openxmlformats.org/officeDocument/2006/relationships">
-  <p:cSld>
-    <p:bg>
-      <p:bgPr>
-        <a:solidFill>
-          <a:srgbClr val="020617"/>
-        </a:solidFill>
-        <a:effectLst/>
-      </p:bgPr>
-    </p:bg>
-    <p:spTree>
-      <p:nvGrpSpPr>
-        <p:cNvPr id="1" name=""/>
-        <p:cNvGrpSpPr/>
-        <p:nvPr/>
-      </p:nvGrpSpPr>
-      <p:grpSpPr/>
-      <p:sp>
-        <p:nvSpPr>
-          <p:cNvPr id="2" name="Rectangle 1"/>
-          <p:cNvSpPr/>
-          <p:nvPr/>
-        </p:nvSpPr>
-        <p:spPr>
-          <a:xfrm>
-            <a:off x="0" y="0"/>
-            <a:ext cx="128016" cy="6858000"/>
-          </a:xfrm>
-          <a:prstGeom prst="rect">
-            <a:avLst/>
-          </a:prstGeom>
-          <a:solidFill>
-            <a:srgbClr val="22D37A"/>
-          </a:solidFill>
-          <a:ln>
-            <a:noFill/>
-          </a:ln>
-        </p:spPr>
-        <p:style>
-          <a:lnRef idx="1">
-            <a:schemeClr val="accent1"/>
-          </a:lnRef>
-          <a:fillRef idx="3">
-            <a:schemeClr val="accent1"/>
-          </a:fillRef>
-          <a:effectRef idx="2">
-            <a:schemeClr val="accent1"/>
-          </a:effectRef>
-          <a:fontRef idx="minor">
-            <a:schemeClr val="lt1"/>
-          </a:fontRef>
-        </p:style>
-        <p:txBody>
-          <a:bodyPr rtlCol="0" anchor="ctr"/>
-          <a:lstStyle/>
-          <a:p>
-            <a:pPr algn="ctr"/>
-          </a:p>
-        </p:txBody>
-      </p:sp>
-      <p:sp>
-        <p:nvSpPr>
-          <p:cNvPr id="3" name="TextBox 2"/>
-          <p:cNvSpPr txBox="1"/>
-          <p:nvPr/>
-        </p:nvSpPr>
-        <p:spPr>
-          <a:xfrm>
-            <a:off x="640080" y="457200"/>
-            <a:ext cx="10972800" cy="457200"/>
-          </a:xfrm>
-          <a:prstGeom prst="rect">
-            <a:avLst/>
-          </a:prstGeom>
-          <a:noFill/>
-        </p:spPr>
-        <p:txBody>
-          <a:bodyPr wrap="square" anchor="t">
-            <a:spAutoFit/>
-          </a:bodyPr>
-          <a:lstStyle/>
-          <a:p>
-            <a:pPr algn="l">
-              <a:spcAft>
-                <a:spcPts val="800"/>
-              </a:spcAft>
-            </a:pPr>
-            <a:r>
-              <a:rPr sz="1300" b="1">
-                <a:solidFill>
-                  <a:srgbClr val="22D37A"/>
-                </a:solidFill>
-                <a:latin typeface="Consolas"/>
-              </a:rPr>
-              <a:t>IT ANSWERS A REAL ASK</a:t>
-            </a:r>
-          </a:p>
-        </p:txBody>
-      </p:sp>
-      <p:sp>
-        <p:nvSpPr>
-          <p:cNvPr id="4" name="TextBox 3"/>
-          <p:cNvSpPr txBox="1"/>
-          <p:nvPr/>
-        </p:nvSpPr>
-        <p:spPr>
-          <a:xfrm>
-            <a:off x="640080" y="868680"/>
-            <a:ext cx="10972800" cy="1188720"/>
-          </a:xfrm>
-          <a:prstGeom prst="rect">
-            <a:avLst/>
-          </a:prstGeom>
-          <a:noFill/>
-        </p:spPr>
-        <p:txBody>
-          <a:bodyPr wrap="square" anchor="t">
-            <a:spAutoFit/>
-          </a:bodyPr>
-          <a:lstStyle/>
-          <a:p>
-            <a:pPr algn="l">
-              <a:spcAft>
-                <a:spcPts val="800"/>
-              </a:spcAft>
-            </a:pPr>
-            <a:r>
-              <a:rPr sz="4000" b="1">
-                <a:solidFill>
-                  <a:srgbClr val="E9F0FA"/>
-                </a:solidFill>
-                <a:latin typeface="Segoe UI"/>
-              </a:rPr>
-              <a:t>The Ministry's own problem statement</a:t>
-            </a:r>
-          </a:p>
-        </p:txBody>
-      </p:sp>
-      <p:sp>
-        <p:nvSpPr>
-          <p:cNvPr id="5" name="TextBox 4"/>
-          <p:cNvSpPr txBox="1"/>
-          <p:nvPr/>
-        </p:nvSpPr>
-        <p:spPr>
-          <a:xfrm>
-            <a:off x="640080" y="2011680"/>
-            <a:ext cx="10515600" cy="4206240"/>
-          </a:xfrm>
-          <a:prstGeom prst="rect">
-            <a:avLst/>
-          </a:prstGeom>
-          <a:noFill/>
-        </p:spPr>
-        <p:txBody>
-          <a:bodyPr wrap="square" anchor="t">
-            <a:spAutoFit/>
-          </a:bodyPr>
-          <a:lstStyle/>
-          <a:p>
-            <a:pPr algn="l">
-              <a:spcAft>
-                <a:spcPts val="1400"/>
-              </a:spcAft>
-            </a:pPr>
-            <a:r>
-              <a:rPr sz="1900" b="0">
-                <a:solidFill>
-                  <a:srgbClr val="22D37A"/>
-                </a:solidFill>
-                <a:latin typeface="Segoe UI"/>
-              </a:rPr>
-              <a:t>SIH25022, Ministry of Railways: "Maximizing section throughput through AI-powered, real-time train traffic control."</a:t>
-            </a:r>
-          </a:p>
-          <a:p>
-            <a:pPr algn="l">
-              <a:spcAft>
-                <a:spcPts val="1400"/>
-              </a:spcAft>
-            </a:pPr>
-            <a:r>
-              <a:rPr sz="1900" b="0">
-                <a:solidFill>
-                  <a:srgbClr val="E9F0FA"/>
-                </a:solidFill>
-                <a:latin typeface="Segoe UI"/>
-              </a:rPr>
-              <a:t>It sits alongside Kavach, not against it. Kavach is the safety-certified anti-collision layer. Pravaah is the throughput and explainability layer above it.</a:t>
-            </a:r>
-          </a:p>
-          <a:p>
-            <a:pPr algn="l">
-              <a:spcAft>
-                <a:spcPts val="1400"/>
-              </a:spcAft>
-            </a:pPr>
-            <a:r>
-              <a:rPr sz="1900" b="0">
-                <a:solidFill>
-                  <a:srgbClr val="9AB0CF"/>
-                </a:solidFill>
-                <a:latin typeface="Segoe UI"/>
-              </a:rPr>
-              <a:t>It is a prototype and a decision-support concept, not certified train control. We say so plainly.</a:t>
-            </a:r>
-          </a:p>
-        </p:txBody>
-      </p:sp>
-    </p:spTree>
-  </p:cSld>
-  <p:clrMapOvr>
-    <a:masterClrMapping/>
-  </p:clrMapOvr>
-</p:sld>
-</file>
-
-<file path=ppt/slides/slide13.xml><?xml version="1.0" encoding="utf-8"?>
-<p:sld xmlns:a="http://schemas.openxmlformats.org/drawingml/2006/main" xmlns:p="http://schemas.openxmlformats.org/presentationml/2006/main" xmlns:r="http://schemas.openxmlformats.org/officeDocument/2006/relationships">
-  <p:cSld>
-    <p:bg>
-      <p:bgPr>
-        <a:solidFill>
-          <a:srgbClr val="020617"/>
-        </a:solidFill>
-        <a:effectLst/>
-      </p:bgPr>
-    </p:bg>
-    <p:spTree>
-      <p:nvGrpSpPr>
-        <p:cNvPr id="1" name=""/>
-        <p:cNvGrpSpPr/>
-        <p:nvPr/>
-      </p:nvGrpSpPr>
-      <p:grpSpPr/>
-      <p:sp>
-        <p:nvSpPr>
-          <p:cNvPr id="2" name="Rectangle 1"/>
-          <p:cNvSpPr/>
-          <p:nvPr/>
-        </p:nvSpPr>
-        <p:spPr>
-          <a:xfrm>
-            <a:off x="0" y="0"/>
-            <a:ext cx="128016" cy="6858000"/>
-          </a:xfrm>
-          <a:prstGeom prst="rect">
-            <a:avLst/>
-          </a:prstGeom>
-          <a:solidFill>
-            <a:srgbClr val="22D37A"/>
-          </a:solidFill>
-          <a:ln>
-            <a:noFill/>
-          </a:ln>
-        </p:spPr>
-        <p:style>
-          <a:lnRef idx="1">
-            <a:schemeClr val="accent1"/>
-          </a:lnRef>
-          <a:fillRef idx="3">
-            <a:schemeClr val="accent1"/>
-          </a:fillRef>
-          <a:effectRef idx="2">
-            <a:schemeClr val="accent1"/>
-          </a:effectRef>
-          <a:fontRef idx="minor">
-            <a:schemeClr val="lt1"/>
-          </a:fontRef>
-        </p:style>
-        <p:txBody>
-          <a:bodyPr rtlCol="0" anchor="ctr"/>
-          <a:lstStyle/>
-          <a:p>
-            <a:pPr algn="ctr"/>
-          </a:p>
-        </p:txBody>
-      </p:sp>
-      <p:sp>
-        <p:nvSpPr>
-          <p:cNvPr id="3" name="TextBox 2"/>
-          <p:cNvSpPr txBox="1"/>
-          <p:nvPr/>
-        </p:nvSpPr>
-        <p:spPr>
-          <a:xfrm>
-            <a:off x="822960" y="2103120"/>
-            <a:ext cx="10515600" cy="2743200"/>
-          </a:xfrm>
-          <a:prstGeom prst="rect">
-            <a:avLst/>
-          </a:prstGeom>
-          <a:noFill/>
-        </p:spPr>
-        <p:txBody>
-          <a:bodyPr wrap="square" anchor="t">
-            <a:spAutoFit/>
-          </a:bodyPr>
-          <a:lstStyle/>
-          <a:p>
-            <a:pPr algn="l">
-              <a:spcAft>
-                <a:spcPts val="800"/>
-              </a:spcAft>
-            </a:pPr>
-            <a:r>
-              <a:rPr sz="4400" b="1">
-                <a:solidFill>
-                  <a:srgbClr val="E9F0FA"/>
-                </a:solidFill>
-                <a:latin typeface="Segoe UI"/>
-              </a:rPr>
-              <a:t>Pravaah · प्रवाह</a:t>
-            </a:r>
-          </a:p>
-          <a:p>
-            <a:pPr algn="l">
-              <a:spcAft>
-                <a:spcPts val="1800"/>
-              </a:spcAft>
-            </a:pPr>
-            <a:r>
-              <a:rPr sz="2200" b="1">
-                <a:solidFill>
-                  <a:srgbClr val="22D37A"/>
-                </a:solidFill>
-                <a:latin typeface="Segoe UI"/>
-              </a:rPr>
-              <a:t>Open. Explainable. Safe by design. The control-room brain Indian Railways does not have yet.</a:t>
-            </a:r>
-          </a:p>
-          <a:p>
-            <a:pPr algn="l">
-              <a:spcAft>
-                <a:spcPts val="800"/>
-              </a:spcAft>
-            </a:pPr>
-            <a:r>
-              <a:rPr sz="1500" b="0">
-                <a:solidFill>
-                  <a:srgbClr val="9AB0CF"/>
-                </a:solidFill>
-                <a:latin typeface="Segoe UI"/>
-              </a:rPr>
-              <a:t>Try it live, then read the code. Both links below.</a:t>
-            </a:r>
-          </a:p>
-        </p:txBody>
-      </p:sp>
-      <p:sp>
-        <p:nvSpPr>
-          <p:cNvPr id="4" name="TextBox 3"/>
-          <p:cNvSpPr txBox="1"/>
-          <p:nvPr/>
-        </p:nvSpPr>
-        <p:spPr>
-          <a:xfrm>
-            <a:off x="640080" y="6400800"/>
-            <a:ext cx="10972800" cy="365760"/>
-          </a:xfrm>
-          <a:prstGeom prst="rect">
-            <a:avLst/>
-          </a:prstGeom>
-          <a:noFill/>
-        </p:spPr>
-        <p:txBody>
-          <a:bodyPr wrap="square" anchor="t">
-            <a:spAutoFit/>
-          </a:bodyPr>
-          <a:lstStyle/>
-          <a:p>
-            <a:pPr algn="l">
-              <a:spcAft>
-                <a:spcPts val="800"/>
-              </a:spcAft>
-            </a:pPr>
-            <a:r>
-              <a:rPr sz="1100" b="0">
-                <a:solidFill>
-                  <a:srgbClr val="9AB0CF"/>
-                </a:solidFill>
-                <a:latin typeface="Consolas"/>
-              </a:rPr>
-              <a:t>garvitsurana271.github.io/pravaah   ·   github.com/garvitsurana271/pravaah   ·   FAR AWAY 2026</a:t>
+              <a:t>LIVE  garvitsurana271.github.io/pravaah      CODE  github.com/garvitsurana271/pravaah</a:t>
             </a:r>
           </a:p>
         </p:txBody>
@@ -4168,49 +3256,30 @@
         <p:nvPr/>
       </p:nvGrpSpPr>
       <p:grpSpPr/>
-      <p:sp>
-        <p:nvSpPr>
-          <p:cNvPr id="2" name="Rectangle 1"/>
-          <p:cNvSpPr/>
+      <p:pic>
+        <p:nvPicPr>
+          <p:cNvPr id="2" name="Picture 1" descr="control-room.png"/>
+          <p:cNvPicPr>
+            <a:picLocks noChangeAspect="1"/>
+          </p:cNvPicPr>
           <p:nvPr/>
-        </p:nvSpPr>
-        <p:spPr>
-          <a:xfrm>
-            <a:off x="0" y="0"/>
-            <a:ext cx="128016" cy="6858000"/>
+        </p:nvPicPr>
+        <p:blipFill>
+          <a:blip r:embed="rId2"/>
+          <a:stretch>
+            <a:fillRect/>
+          </a:stretch>
+        </p:blipFill>
+        <p:spPr>
+          <a:xfrm>
+            <a:off x="1743303" y="566928"/>
+            <a:ext cx="8705088" cy="5440680"/>
           </a:xfrm>
           <a:prstGeom prst="rect">
             <a:avLst/>
           </a:prstGeom>
-          <a:solidFill>
-            <a:srgbClr val="FF4D4D"/>
-          </a:solidFill>
-          <a:ln>
-            <a:noFill/>
-          </a:ln>
-        </p:spPr>
-        <p:style>
-          <a:lnRef idx="1">
-            <a:schemeClr val="accent1"/>
-          </a:lnRef>
-          <a:fillRef idx="3">
-            <a:schemeClr val="accent1"/>
-          </a:fillRef>
-          <a:effectRef idx="2">
-            <a:schemeClr val="accent1"/>
-          </a:effectRef>
-          <a:fontRef idx="minor">
-            <a:schemeClr val="lt1"/>
-          </a:fontRef>
-        </p:style>
-        <p:txBody>
-          <a:bodyPr rtlCol="0" anchor="ctr"/>
-          <a:lstStyle/>
-          <a:p>
-            <a:pPr algn="ctr"/>
-          </a:p>
-        </p:txBody>
-      </p:sp>
+        </p:spPr>
+      </p:pic>
       <p:sp>
         <p:nvSpPr>
           <p:cNvPr id="3" name="TextBox 2"/>
@@ -4219,8 +3288,8 @@
         </p:nvSpPr>
         <p:spPr>
           <a:xfrm>
-            <a:off x="640080" y="457200"/>
-            <a:ext cx="10972800" cy="457200"/>
+            <a:off x="640080" y="182880"/>
+            <a:ext cx="10972800" cy="365760"/>
           </a:xfrm>
           <a:prstGeom prst="rect">
             <a:avLst/>
@@ -4233,19 +3302,19 @@
           </a:bodyPr>
           <a:lstStyle/>
           <a:p>
-            <a:pPr algn="l">
+            <a:pPr algn="ctr">
               <a:spcAft>
                 <a:spcPts val="800"/>
               </a:spcAft>
             </a:pPr>
             <a:r>
-              <a:rPr sz="1300" b="1">
-                <a:solidFill>
-                  <a:srgbClr val="FF4D4D"/>
+              <a:rPr sz="1200" b="1">
+                <a:solidFill>
+                  <a:srgbClr val="3AA0FF"/>
                 </a:solidFill>
                 <a:latin typeface="Consolas"/>
               </a:rPr>
-              <a:t>THE PROBLEM, PART 1</a:t>
+              <a:t>THIS IS REAL AND RUNNING</a:t>
             </a:r>
           </a:p>
         </p:txBody>
@@ -4258,8 +3327,8 @@
         </p:nvSpPr>
         <p:spPr>
           <a:xfrm>
-            <a:off x="640080" y="868680"/>
-            <a:ext cx="10972800" cy="1188720"/>
+            <a:off x="640080" y="6172200"/>
+            <a:ext cx="10908792" cy="548640"/>
           </a:xfrm>
           <a:prstGeom prst="rect">
             <a:avLst/>
@@ -4272,90 +3341,19 @@
           </a:bodyPr>
           <a:lstStyle/>
           <a:p>
-            <a:pPr algn="l">
+            <a:pPr algn="ctr">
               <a:spcAft>
                 <a:spcPts val="800"/>
               </a:spcAft>
             </a:pPr>
             <a:r>
-              <a:rPr sz="4000" b="1">
-                <a:solidFill>
-                  <a:srgbClr val="E9F0FA"/>
-                </a:solidFill>
-                <a:latin typeface="Segoe UI"/>
+              <a:rPr sz="1500" b="0">
+                <a:solidFill>
+                  <a:srgbClr val="ECF2FB"/>
+                </a:solidFill>
+                <a:latin typeface="Segoe UI Semibold"/>
               </a:rPr>
-              <a:t>A signalling failure put two trains on one track</a:t>
-            </a:r>
-          </a:p>
-        </p:txBody>
-      </p:sp>
-      <p:sp>
-        <p:nvSpPr>
-          <p:cNvPr id="5" name="TextBox 4"/>
-          <p:cNvSpPr txBox="1"/>
-          <p:nvPr/>
-        </p:nvSpPr>
-        <p:spPr>
-          <a:xfrm>
-            <a:off x="640080" y="2011680"/>
-            <a:ext cx="10515600" cy="4206240"/>
-          </a:xfrm>
-          <a:prstGeom prst="rect">
-            <a:avLst/>
-          </a:prstGeom>
-          <a:noFill/>
-        </p:spPr>
-        <p:txBody>
-          <a:bodyPr wrap="square" anchor="t">
-            <a:spAutoFit/>
-          </a:bodyPr>
-          <a:lstStyle/>
-          <a:p>
-            <a:pPr algn="l">
-              <a:spcAft>
-                <a:spcPts val="1400"/>
-              </a:spcAft>
-            </a:pPr>
-            <a:r>
-              <a:rPr sz="2000" b="0">
-                <a:solidFill>
-                  <a:srgbClr val="E9F0FA"/>
-                </a:solidFill>
-                <a:latin typeface="Segoe UI"/>
-              </a:rPr>
-              <a:t>2 June 2023. A wrongly-wired circuit sent the Coromandel Express onto an occupied loop line at 128 km/h near Bahanaga Bazar, Balasore.</a:t>
-            </a:r>
-          </a:p>
-          <a:p>
-            <a:pPr algn="l">
-              <a:spcAft>
-                <a:spcPts val="1400"/>
-              </a:spcAft>
-            </a:pPr>
-            <a:r>
-              <a:rPr sz="2000" b="0">
-                <a:solidFill>
-                  <a:srgbClr val="FF4D4D"/>
-                </a:solidFill>
-                <a:latin typeface="Segoe UI"/>
-              </a:rPr>
-              <a:t>Close to 300 people died. The line had no Kavach.</a:t>
-            </a:r>
-          </a:p>
-          <a:p>
-            <a:pPr algn="l">
-              <a:spcAft>
-                <a:spcPts val="1400"/>
-              </a:spcAft>
-            </a:pPr>
-            <a:r>
-              <a:rPr sz="2000" b="0">
-                <a:solidFill>
-                  <a:srgbClr val="9AB0CF"/>
-                </a:solidFill>
-                <a:latin typeface="Segoe UI"/>
-              </a:rPr>
-              <a:t>A year later a goods train ran a red signal and killed ten more on the Kanchanjunga Express. Again, no Kavach.</a:t>
+              <a:t>Two dispatchers on the same trains: an AI optimizer, and how it is done today.</a:t>
             </a:r>
           </a:p>
         </p:txBody>
@@ -4388,56 +3386,13 @@
       <p:grpSpPr/>
       <p:sp>
         <p:nvSpPr>
-          <p:cNvPr id="2" name="Rectangle 1"/>
-          <p:cNvSpPr/>
-          <p:nvPr/>
-        </p:nvSpPr>
-        <p:spPr>
-          <a:xfrm>
-            <a:off x="0" y="0"/>
-            <a:ext cx="128016" cy="6858000"/>
-          </a:xfrm>
-          <a:prstGeom prst="rect">
-            <a:avLst/>
-          </a:prstGeom>
-          <a:solidFill>
-            <a:srgbClr val="FFB02E"/>
-          </a:solidFill>
-          <a:ln>
-            <a:noFill/>
-          </a:ln>
-        </p:spPr>
-        <p:style>
-          <a:lnRef idx="1">
-            <a:schemeClr val="accent1"/>
-          </a:lnRef>
-          <a:fillRef idx="3">
-            <a:schemeClr val="accent1"/>
-          </a:fillRef>
-          <a:effectRef idx="2">
-            <a:schemeClr val="accent1"/>
-          </a:effectRef>
-          <a:fontRef idx="minor">
-            <a:schemeClr val="lt1"/>
-          </a:fontRef>
-        </p:style>
-        <p:txBody>
-          <a:bodyPr rtlCol="0" anchor="ctr"/>
-          <a:lstStyle/>
-          <a:p>
-            <a:pPr algn="ctr"/>
-          </a:p>
-        </p:txBody>
-      </p:sp>
-      <p:sp>
-        <p:nvSpPr>
-          <p:cNvPr id="3" name="TextBox 2"/>
+          <p:cNvPr id="2" name="TextBox 1"/>
           <p:cNvSpPr txBox="1"/>
           <p:nvPr/>
         </p:nvSpPr>
         <p:spPr>
           <a:xfrm>
-            <a:off x="640080" y="457200"/>
+            <a:off x="640080" y="1371600"/>
             <a:ext cx="10972800" cy="457200"/>
           </a:xfrm>
           <a:prstGeom prst="rect">
@@ -4451,33 +3406,33 @@
           </a:bodyPr>
           <a:lstStyle/>
           <a:p>
-            <a:pPr algn="l">
+            <a:pPr algn="ctr">
               <a:spcAft>
                 <a:spcPts val="800"/>
               </a:spcAft>
             </a:pPr>
             <a:r>
-              <a:rPr sz="1300" b="1">
-                <a:solidFill>
-                  <a:srgbClr val="FFB02E"/>
+              <a:rPr sz="1400" b="1">
+                <a:solidFill>
+                  <a:srgbClr val="9AB0CF"/>
                 </a:solidFill>
                 <a:latin typeface="Consolas"/>
               </a:rPr>
-              <a:t>THE PROBLEM, PART 2</a:t>
-            </a:r>
-          </a:p>
-        </p:txBody>
-      </p:sp>
-      <p:sp>
-        <p:nvSpPr>
-          <p:cNvPr id="4" name="TextBox 3"/>
+              <a:t>THE RESULT</a:t>
+            </a:r>
+          </a:p>
+        </p:txBody>
+      </p:sp>
+      <p:sp>
+        <p:nvSpPr>
+          <p:cNvPr id="3" name="TextBox 2"/>
           <p:cNvSpPr txBox="1"/>
           <p:nvPr/>
         </p:nvSpPr>
         <p:spPr>
           <a:xfrm>
-            <a:off x="640080" y="868680"/>
-            <a:ext cx="10972800" cy="1188720"/>
+            <a:off x="640080" y="2011680"/>
+            <a:ext cx="10972800" cy="2194560"/>
           </a:xfrm>
           <a:prstGeom prst="rect">
             <a:avLst/>
@@ -4490,33 +3445,33 @@
           </a:bodyPr>
           <a:lstStyle/>
           <a:p>
-            <a:pPr algn="l">
+            <a:pPr algn="ctr">
               <a:spcAft>
                 <a:spcPts val="800"/>
               </a:spcAft>
             </a:pPr>
             <a:r>
-              <a:rPr sz="4000" b="1">
-                <a:solidFill>
-                  <a:srgbClr val="E9F0FA"/>
-                </a:solidFill>
-                <a:latin typeface="Segoe UI"/>
+              <a:rPr sz="15000" b="1">
+                <a:solidFill>
+                  <a:srgbClr val="22D37A"/>
+                </a:solidFill>
+                <a:latin typeface="Segoe UI Semibold"/>
               </a:rPr>
-              <a:t>Indian Railways still dispatches by hand</a:t>
-            </a:r>
-          </a:p>
-        </p:txBody>
-      </p:sp>
-      <p:sp>
-        <p:nvSpPr>
-          <p:cNvPr id="5" name="TextBox 4"/>
+              <a:t>20%</a:t>
+            </a:r>
+          </a:p>
+        </p:txBody>
+      </p:sp>
+      <p:sp>
+        <p:nvSpPr>
+          <p:cNvPr id="4" name="TextBox 3"/>
           <p:cNvSpPr txBox="1"/>
           <p:nvPr/>
         </p:nvSpPr>
         <p:spPr>
           <a:xfrm>
-            <a:off x="640080" y="2011680"/>
-            <a:ext cx="10515600" cy="4206240"/>
+            <a:off x="1280160" y="4526280"/>
+            <a:ext cx="9601200" cy="548640"/>
           </a:xfrm>
           <a:prstGeom prst="rect">
             <a:avLst/>
@@ -4529,67 +3484,58 @@
           </a:bodyPr>
           <a:lstStyle/>
           <a:p>
-            <a:pPr algn="l">
+            <a:pPr algn="ctr">
               <a:spcAft>
-                <a:spcPts val="1400"/>
+                <a:spcPts val="800"/>
               </a:spcAft>
             </a:pPr>
             <a:r>
-              <a:rPr sz="2000" b="0">
-                <a:solidFill>
-                  <a:srgbClr val="E9F0FA"/>
-                </a:solidFill>
-                <a:latin typeface="Segoe UI"/>
+              <a:rPr sz="2400" b="1">
+                <a:solidFill>
+                  <a:srgbClr val="ECF2FB"/>
+                </a:solidFill>
+                <a:latin typeface="Segoe UI Semibold"/>
               </a:rPr>
-              <a:t>A human section controller decides every crossing and every precedence call from experience.</a:t>
-            </a:r>
-          </a:p>
-          <a:p>
-            <a:pPr algn="l">
+              <a:t>less delay than dispatching by hand</a:t>
+            </a:r>
+          </a:p>
+        </p:txBody>
+      </p:sp>
+      <p:sp>
+        <p:nvSpPr>
+          <p:cNvPr id="5" name="TextBox 4"/>
+          <p:cNvSpPr txBox="1"/>
+          <p:nvPr/>
+        </p:nvSpPr>
+        <p:spPr>
+          <a:xfrm>
+            <a:off x="1737360" y="5166360"/>
+            <a:ext cx="8686800" cy="914400"/>
+          </a:xfrm>
+          <a:prstGeom prst="rect">
+            <a:avLst/>
+          </a:prstGeom>
+          <a:noFill/>
+        </p:spPr>
+        <p:txBody>
+          <a:bodyPr wrap="square" anchor="t">
+            <a:spAutoFit/>
+          </a:bodyPr>
+          <a:lstStyle/>
+          <a:p>
+            <a:pPr algn="ctr">
               <a:spcAft>
-                <a:spcPts val="1400"/>
+                <a:spcPts val="800"/>
               </a:spcAft>
             </a:pPr>
             <a:r>
-              <a:rPr sz="2000" b="0">
+              <a:rPr sz="1500" b="0">
                 <a:solidFill>
                   <a:srgbClr val="9AB0CF"/>
                 </a:solidFill>
-                <a:latin typeface="Segoe UI"/>
+                <a:latin typeface="Segoe UI Semibold"/>
               </a:rPr>
-              <a:t>The control-room software draws charts and shows where trains are. It does not make the decision.</a:t>
-            </a:r>
-          </a:p>
-          <a:p>
-            <a:pPr algn="l">
-              <a:spcAft>
-                <a:spcPts val="1400"/>
-              </a:spcAft>
-            </a:pPr>
-            <a:r>
-              <a:rPr sz="2000" b="0">
-                <a:solidFill>
-                  <a:srgbClr val="FFB02E"/>
-                </a:solidFill>
-                <a:latin typeface="Segoe UI"/>
-              </a:rPr>
-              <a:t>Punctuality fell from 94% to about 74% in three years.</a:t>
-            </a:r>
-          </a:p>
-          <a:p>
-            <a:pPr algn="l">
-              <a:spcAft>
-                <a:spcPts val="1400"/>
-              </a:spcAft>
-            </a:pPr>
-            <a:r>
-              <a:rPr sz="2000" b="0">
-                <a:solidFill>
-                  <a:srgbClr val="FFB02E"/>
-                </a:solidFill>
-                <a:latin typeface="Segoe UI"/>
-              </a:rPr>
-              <a:t>Most of the busiest corridors now run above their rated capacity.</a:t>
+              <a:t>Same trains, same track. The AI just sets smarter precedence at every crossing. The other dispatcher is first-come, first-served, the way it works today.</a:t>
             </a:r>
           </a:p>
         </p:txBody>
@@ -4620,49 +3566,30 @@
         <p:nvPr/>
       </p:nvGrpSpPr>
       <p:grpSpPr/>
-      <p:sp>
-        <p:nvSpPr>
-          <p:cNvPr id="2" name="Rectangle 1"/>
-          <p:cNvSpPr/>
+      <p:pic>
+        <p:nvPicPr>
+          <p:cNvPr id="2" name="Picture 1" descr="glass-box.png"/>
+          <p:cNvPicPr>
+            <a:picLocks noChangeAspect="1"/>
+          </p:cNvPicPr>
           <p:nvPr/>
-        </p:nvSpPr>
-        <p:spPr>
-          <a:xfrm>
-            <a:off x="0" y="0"/>
-            <a:ext cx="128016" cy="6858000"/>
+        </p:nvPicPr>
+        <p:blipFill>
+          <a:blip r:embed="rId2"/>
+          <a:stretch>
+            <a:fillRect/>
+          </a:stretch>
+        </p:blipFill>
+        <p:spPr>
+          <a:xfrm>
+            <a:off x="4907926" y="566928"/>
+            <a:ext cx="2375842" cy="5440680"/>
           </a:xfrm>
           <a:prstGeom prst="rect">
             <a:avLst/>
           </a:prstGeom>
-          <a:solidFill>
-            <a:srgbClr val="22D37A"/>
-          </a:solidFill>
-          <a:ln>
-            <a:noFill/>
-          </a:ln>
-        </p:spPr>
-        <p:style>
-          <a:lnRef idx="1">
-            <a:schemeClr val="accent1"/>
-          </a:lnRef>
-          <a:fillRef idx="3">
-            <a:schemeClr val="accent1"/>
-          </a:fillRef>
-          <a:effectRef idx="2">
-            <a:schemeClr val="accent1"/>
-          </a:effectRef>
-          <a:fontRef idx="minor">
-            <a:schemeClr val="lt1"/>
-          </a:fontRef>
-        </p:style>
-        <p:txBody>
-          <a:bodyPr rtlCol="0" anchor="ctr"/>
-          <a:lstStyle/>
-          <a:p>
-            <a:pPr algn="ctr"/>
-          </a:p>
-        </p:txBody>
-      </p:sp>
+        </p:spPr>
+      </p:pic>
       <p:sp>
         <p:nvSpPr>
           <p:cNvPr id="3" name="TextBox 2"/>
@@ -4671,8 +3598,8 @@
         </p:nvSpPr>
         <p:spPr>
           <a:xfrm>
-            <a:off x="640080" y="457200"/>
-            <a:ext cx="10972800" cy="457200"/>
+            <a:off x="640080" y="182880"/>
+            <a:ext cx="10972800" cy="365760"/>
           </a:xfrm>
           <a:prstGeom prst="rect">
             <a:avLst/>
@@ -4685,19 +3612,19 @@
           </a:bodyPr>
           <a:lstStyle/>
           <a:p>
-            <a:pPr algn="l">
+            <a:pPr algn="ctr">
               <a:spcAft>
                 <a:spcPts val="800"/>
               </a:spcAft>
             </a:pPr>
             <a:r>
-              <a:rPr sz="1300" b="1">
+              <a:rPr sz="1200" b="1">
                 <a:solidFill>
                   <a:srgbClr val="22D37A"/>
                 </a:solidFill>
                 <a:latin typeface="Consolas"/>
               </a:rPr>
-              <a:t>THE GAP WE FILL</a:t>
+              <a:t>WHAT MAKES IT DIFFERENT</a:t>
             </a:r>
           </a:p>
         </p:txBody>
@@ -4710,8 +3637,8 @@
         </p:nvSpPr>
         <p:spPr>
           <a:xfrm>
-            <a:off x="640080" y="868680"/>
-            <a:ext cx="10972800" cy="1188720"/>
+            <a:off x="640080" y="6172200"/>
+            <a:ext cx="10908792" cy="548640"/>
           </a:xfrm>
           <a:prstGeom prst="rect">
             <a:avLst/>
@@ -4724,106 +3651,19 @@
           </a:bodyPr>
           <a:lstStyle/>
           <a:p>
-            <a:pPr algn="l">
+            <a:pPr algn="ctr">
               <a:spcAft>
                 <a:spcPts val="800"/>
               </a:spcAft>
             </a:pPr>
             <a:r>
-              <a:rPr sz="4000" b="1">
-                <a:solidFill>
-                  <a:srgbClr val="E9F0FA"/>
-                </a:solidFill>
-                <a:latin typeface="Segoe UI"/>
+              <a:rPr sz="1500" b="0">
+                <a:solidFill>
+                  <a:srgbClr val="ECF2FB"/>
+                </a:solidFill>
+                <a:latin typeface="Segoe UI Semibold"/>
               </a:rPr>
-              <a:t>Closed systems that cost crores, or nothing at all</a:t>
-            </a:r>
-          </a:p>
-        </p:txBody>
-      </p:sp>
-      <p:sp>
-        <p:nvSpPr>
-          <p:cNvPr id="5" name="TextBox 4"/>
-          <p:cNvSpPr txBox="1"/>
-          <p:nvPr/>
-        </p:nvSpPr>
-        <p:spPr>
-          <a:xfrm>
-            <a:off x="640080" y="2011680"/>
-            <a:ext cx="10515600" cy="4206240"/>
-          </a:xfrm>
-          <a:prstGeom prst="rect">
-            <a:avLst/>
-          </a:prstGeom>
-          <a:noFill/>
-        </p:spPr>
-        <p:txBody>
-          <a:bodyPr wrap="square" anchor="t">
-            <a:spAutoFit/>
-          </a:bodyPr>
-          <a:lstStyle/>
-          <a:p>
-            <a:pPr algn="l">
-              <a:spcAft>
-                <a:spcPts val="1400"/>
-              </a:spcAft>
-            </a:pPr>
-            <a:r>
-              <a:rPr sz="1800" b="0">
-                <a:solidFill>
-                  <a:srgbClr val="E9F0FA"/>
-                </a:solidFill>
-                <a:latin typeface="Segoe UI"/>
-              </a:rPr>
-              <a:t>Hitachi, Siemens and Alstom sell AI traffic management as closed systems above a thousand crore, and even those stay advisory because controllers do not trust a black box.</a:t>
-            </a:r>
-          </a:p>
-          <a:p>
-            <a:pPr algn="l">
-              <a:spcAft>
-                <a:spcPts val="1400"/>
-              </a:spcAft>
-            </a:pPr>
-            <a:r>
-              <a:rPr sz="1800" b="0">
-                <a:solidFill>
-                  <a:srgbClr val="22D37A"/>
-                </a:solidFill>
-                <a:latin typeface="Segoe UI"/>
-              </a:rPr>
-              <a:t>There is no open, India-specific, explainable tool for this.</a:t>
-            </a:r>
-          </a:p>
-          <a:p>
-            <a:pPr algn="l">
-              <a:spcAft>
-                <a:spcPts val="1400"/>
-              </a:spcAft>
-            </a:pPr>
-            <a:r>
-              <a:rPr sz="1800" b="0">
-                <a:solidFill>
-                  <a:srgbClr val="9AB0CF"/>
-                </a:solidFill>
-                <a:latin typeface="Segoe UI"/>
-              </a:rPr>
-              <a:t>Our contribution is the combination, not the math: open, explainable, India-specific, with safety as a hard floor.</a:t>
-            </a:r>
-          </a:p>
-          <a:p>
-            <a:pPr algn="l">
-              <a:spcAft>
-                <a:spcPts val="1400"/>
-              </a:spcAft>
-            </a:pPr>
-            <a:r>
-              <a:rPr sz="1800" b="0">
-                <a:solidFill>
-                  <a:srgbClr val="9AB0CF"/>
-                </a:solidFill>
-                <a:latin typeface="Segoe UI"/>
-              </a:rPr>
-              <a:t>We did not use reinforcement learning on purpose. The evidence (the Flatland challenge) shows classical optimization beats it and RL has never been deployed.</a:t>
+              <a:t>It explains every call in plain words, from the optimizer's own numbers. No black box.</a:t>
             </a:r>
           </a:p>
         </p:txBody>
@@ -4854,130 +3694,9 @@
         <p:nvPr/>
       </p:nvGrpSpPr>
       <p:grpSpPr/>
-      <p:sp>
-        <p:nvSpPr>
-          <p:cNvPr id="2" name="Rectangle 1"/>
-          <p:cNvSpPr/>
-          <p:nvPr/>
-        </p:nvSpPr>
-        <p:spPr>
-          <a:xfrm>
-            <a:off x="0" y="0"/>
-            <a:ext cx="128016" cy="6858000"/>
-          </a:xfrm>
-          <a:prstGeom prst="rect">
-            <a:avLst/>
-          </a:prstGeom>
-          <a:solidFill>
-            <a:srgbClr val="3AA0FF"/>
-          </a:solidFill>
-          <a:ln>
-            <a:noFill/>
-          </a:ln>
-        </p:spPr>
-        <p:style>
-          <a:lnRef idx="1">
-            <a:schemeClr val="accent1"/>
-          </a:lnRef>
-          <a:fillRef idx="3">
-            <a:schemeClr val="accent1"/>
-          </a:fillRef>
-          <a:effectRef idx="2">
-            <a:schemeClr val="accent1"/>
-          </a:effectRef>
-          <a:fontRef idx="minor">
-            <a:schemeClr val="lt1"/>
-          </a:fontRef>
-        </p:style>
-        <p:txBody>
-          <a:bodyPr rtlCol="0" anchor="ctr"/>
-          <a:lstStyle/>
-          <a:p>
-            <a:pPr algn="ctr"/>
-          </a:p>
-        </p:txBody>
-      </p:sp>
-      <p:sp>
-        <p:nvSpPr>
-          <p:cNvPr id="3" name="TextBox 2"/>
-          <p:cNvSpPr txBox="1"/>
-          <p:nvPr/>
-        </p:nvSpPr>
-        <p:spPr>
-          <a:xfrm>
-            <a:off x="640080" y="457200"/>
-            <a:ext cx="10972800" cy="457200"/>
-          </a:xfrm>
-          <a:prstGeom prst="rect">
-            <a:avLst/>
-          </a:prstGeom>
-          <a:noFill/>
-        </p:spPr>
-        <p:txBody>
-          <a:bodyPr wrap="square" anchor="t">
-            <a:spAutoFit/>
-          </a:bodyPr>
-          <a:lstStyle/>
-          <a:p>
-            <a:pPr algn="l">
-              <a:spcAft>
-                <a:spcPts val="800"/>
-              </a:spcAft>
-            </a:pPr>
-            <a:r>
-              <a:rPr sz="1300" b="1">
-                <a:solidFill>
-                  <a:srgbClr val="22D37A"/>
-                </a:solidFill>
-                <a:latin typeface="Consolas"/>
-              </a:rPr>
-              <a:t>THE PRODUCT</a:t>
-            </a:r>
-          </a:p>
-        </p:txBody>
-      </p:sp>
-      <p:sp>
-        <p:nvSpPr>
-          <p:cNvPr id="4" name="TextBox 3"/>
-          <p:cNvSpPr txBox="1"/>
-          <p:nvPr/>
-        </p:nvSpPr>
-        <p:spPr>
-          <a:xfrm>
-            <a:off x="640080" y="868680"/>
-            <a:ext cx="10972800" cy="1188720"/>
-          </a:xfrm>
-          <a:prstGeom prst="rect">
-            <a:avLst/>
-          </a:prstGeom>
-          <a:noFill/>
-        </p:spPr>
-        <p:txBody>
-          <a:bodyPr wrap="square" anchor="t">
-            <a:spAutoFit/>
-          </a:bodyPr>
-          <a:lstStyle/>
-          <a:p>
-            <a:pPr algn="l">
-              <a:spcAft>
-                <a:spcPts val="800"/>
-              </a:spcAft>
-            </a:pPr>
-            <a:r>
-              <a:rPr sz="3400" b="1">
-                <a:solidFill>
-                  <a:srgbClr val="E9F0FA"/>
-                </a:solidFill>
-                <a:latin typeface="Segoe UI"/>
-              </a:rPr>
-              <a:t>A live control room for one busy section</a:t>
-            </a:r>
-          </a:p>
-        </p:txBody>
-      </p:sp>
       <p:pic>
         <p:nvPicPr>
-          <p:cNvPr id="5" name="Picture 4" descr="control-room.png"/>
+          <p:cNvPr id="2" name="Picture 1" descr="safety-hold.png"/>
           <p:cNvPicPr>
             <a:picLocks noChangeAspect="1"/>
           </p:cNvPicPr>
@@ -4991,8 +3710,8 @@
         </p:blipFill>
         <p:spPr>
           <a:xfrm>
-            <a:off x="640080" y="1874519"/>
-            <a:ext cx="10972800" cy="6858000"/>
+            <a:off x="1743303" y="566928"/>
+            <a:ext cx="8705088" cy="5440680"/>
           </a:xfrm>
           <a:prstGeom prst="rect">
             <a:avLst/>
@@ -5001,13 +3720,13 @@
       </p:pic>
       <p:sp>
         <p:nvSpPr>
-          <p:cNvPr id="6" name="TextBox 5"/>
+          <p:cNvPr id="3" name="TextBox 2"/>
           <p:cNvSpPr txBox="1"/>
           <p:nvPr/>
         </p:nvSpPr>
         <p:spPr>
           <a:xfrm>
-            <a:off x="640080" y="6400800"/>
+            <a:off x="640080" y="182880"/>
             <a:ext cx="10972800" cy="365760"/>
           </a:xfrm>
           <a:prstGeom prst="rect">
@@ -5021,19 +3740,58 @@
           </a:bodyPr>
           <a:lstStyle/>
           <a:p>
-            <a:pPr algn="l">
+            <a:pPr algn="ctr">
               <a:spcAft>
                 <a:spcPts val="800"/>
               </a:spcAft>
             </a:pPr>
             <a:r>
-              <a:rPr sz="1100" b="0">
-                <a:solidFill>
-                  <a:srgbClr val="9AB0CF"/>
+              <a:rPr sz="1200" b="1">
+                <a:solidFill>
+                  <a:srgbClr val="FF4D4D"/>
                 </a:solidFill>
                 <a:latin typeface="Consolas"/>
               </a:rPr>
-              <a:t>Two dispatchers run on the same trains: the AI optimizer, and first-come-first-served, which is how it is done today.</a:t>
+              <a:t>SAFE BY DESIGN</a:t>
+            </a:r>
+          </a:p>
+        </p:txBody>
+      </p:sp>
+      <p:sp>
+        <p:nvSpPr>
+          <p:cNvPr id="4" name="TextBox 3"/>
+          <p:cNvSpPr txBox="1"/>
+          <p:nvPr/>
+        </p:nvSpPr>
+        <p:spPr>
+          <a:xfrm>
+            <a:off x="640080" y="6172200"/>
+            <a:ext cx="10908792" cy="548640"/>
+          </a:xfrm>
+          <a:prstGeom prst="rect">
+            <a:avLst/>
+          </a:prstGeom>
+          <a:noFill/>
+        </p:spPr>
+        <p:txBody>
+          <a:bodyPr wrap="square" anchor="t">
+            <a:spAutoFit/>
+          </a:bodyPr>
+          <a:lstStyle/>
+          <a:p>
+            <a:pPr algn="ctr">
+              <a:spcAft>
+                <a:spcPts val="800"/>
+              </a:spcAft>
+            </a:pPr>
+            <a:r>
+              <a:rPr sz="1500" b="0">
+                <a:solidFill>
+                  <a:srgbClr val="ECF2FB"/>
+                </a:solidFill>
+                <a:latin typeface="Segoe UI Semibold"/>
+              </a:rPr>
+              <a:t>It refuses to cause a collision. Here it re-stages the 2 June 2023 Balasore failure and blocks it.</a:t>
             </a:r>
           </a:p>
         </p:txBody>
@@ -5066,56 +3824,13 @@
       <p:grpSpPr/>
       <p:sp>
         <p:nvSpPr>
-          <p:cNvPr id="2" name="Rectangle 1"/>
-          <p:cNvSpPr/>
-          <p:nvPr/>
-        </p:nvSpPr>
-        <p:spPr>
-          <a:xfrm>
-            <a:off x="0" y="0"/>
-            <a:ext cx="128016" cy="6858000"/>
-          </a:xfrm>
-          <a:prstGeom prst="rect">
-            <a:avLst/>
-          </a:prstGeom>
-          <a:solidFill>
-            <a:srgbClr val="22D37A"/>
-          </a:solidFill>
-          <a:ln>
-            <a:noFill/>
-          </a:ln>
-        </p:spPr>
-        <p:style>
-          <a:lnRef idx="1">
-            <a:schemeClr val="accent1"/>
-          </a:lnRef>
-          <a:fillRef idx="3">
-            <a:schemeClr val="accent1"/>
-          </a:fillRef>
-          <a:effectRef idx="2">
-            <a:schemeClr val="accent1"/>
-          </a:effectRef>
-          <a:fontRef idx="minor">
-            <a:schemeClr val="lt1"/>
-          </a:fontRef>
-        </p:style>
-        <p:txBody>
-          <a:bodyPr rtlCol="0" anchor="ctr"/>
-          <a:lstStyle/>
-          <a:p>
-            <a:pPr algn="ctr"/>
-          </a:p>
-        </p:txBody>
-      </p:sp>
-      <p:sp>
-        <p:nvSpPr>
-          <p:cNvPr id="3" name="TextBox 2"/>
+          <p:cNvPr id="2" name="TextBox 1"/>
           <p:cNvSpPr txBox="1"/>
           <p:nvPr/>
         </p:nvSpPr>
         <p:spPr>
           <a:xfrm>
-            <a:off x="640080" y="457200"/>
+            <a:off x="640080" y="1371600"/>
             <a:ext cx="10972800" cy="457200"/>
           </a:xfrm>
           <a:prstGeom prst="rect">
@@ -5129,33 +3844,33 @@
           </a:bodyPr>
           <a:lstStyle/>
           <a:p>
-            <a:pPr algn="l">
+            <a:pPr algn="ctr">
               <a:spcAft>
                 <a:spcPts val="800"/>
               </a:spcAft>
             </a:pPr>
             <a:r>
-              <a:rPr sz="1300" b="1">
-                <a:solidFill>
-                  <a:srgbClr val="22D37A"/>
+              <a:rPr sz="1400" b="1">
+                <a:solidFill>
+                  <a:srgbClr val="9AB0CF"/>
                 </a:solidFill>
                 <a:latin typeface="Consolas"/>
               </a:rPr>
-              <a:t>THE RESULT</a:t>
-            </a:r>
-          </a:p>
-        </p:txBody>
-      </p:sp>
-      <p:sp>
-        <p:nvSpPr>
-          <p:cNvPr id="4" name="TextBox 3"/>
+              <a:t>THE SAFETY FLOOR</a:t>
+            </a:r>
+          </a:p>
+        </p:txBody>
+      </p:sp>
+      <p:sp>
+        <p:nvSpPr>
+          <p:cNvPr id="3" name="TextBox 2"/>
           <p:cNvSpPr txBox="1"/>
           <p:nvPr/>
         </p:nvSpPr>
         <p:spPr>
           <a:xfrm>
-            <a:off x="640080" y="868680"/>
-            <a:ext cx="10972800" cy="1188720"/>
+            <a:off x="640080" y="2011680"/>
+            <a:ext cx="10972800" cy="2194560"/>
           </a:xfrm>
           <a:prstGeom prst="rect">
             <a:avLst/>
@@ -5168,33 +3883,33 @@
           </a:bodyPr>
           <a:lstStyle/>
           <a:p>
-            <a:pPr algn="l">
+            <a:pPr algn="ctr">
               <a:spcAft>
                 <a:spcPts val="800"/>
               </a:spcAft>
             </a:pPr>
             <a:r>
-              <a:rPr sz="3400" b="1">
-                <a:solidFill>
-                  <a:srgbClr val="E9F0FA"/>
-                </a:solidFill>
-                <a:latin typeface="Segoe UI"/>
+              <a:rPr sz="15000" b="1">
+                <a:solidFill>
+                  <a:srgbClr val="FF4D4D"/>
+                </a:solidFill>
+                <a:latin typeface="Segoe UI Semibold"/>
               </a:rPr>
-              <a:t>Switch the AI off and the delay climbs</a:t>
-            </a:r>
-          </a:p>
-        </p:txBody>
-      </p:sp>
-      <p:sp>
-        <p:nvSpPr>
-          <p:cNvPr id="5" name="TextBox 4"/>
+              <a:t>0</a:t>
+            </a:r>
+          </a:p>
+        </p:txBody>
+      </p:sp>
+      <p:sp>
+        <p:nvSpPr>
+          <p:cNvPr id="4" name="TextBox 3"/>
           <p:cNvSpPr txBox="1"/>
           <p:nvPr/>
         </p:nvSpPr>
         <p:spPr>
           <a:xfrm>
-            <a:off x="640080" y="2011680"/>
-            <a:ext cx="10515600" cy="4206240"/>
+            <a:off x="1280160" y="4526280"/>
+            <a:ext cx="9601200" cy="548640"/>
           </a:xfrm>
           <a:prstGeom prst="rect">
             <a:avLst/>
@@ -5207,67 +3922,58 @@
           </a:bodyPr>
           <a:lstStyle/>
           <a:p>
-            <a:pPr algn="l">
+            <a:pPr algn="ctr">
               <a:spcAft>
-                <a:spcPts val="1400"/>
+                <a:spcPts val="800"/>
               </a:spcAft>
             </a:pPr>
             <a:r>
-              <a:rPr sz="2000" b="0">
-                <a:solidFill>
-                  <a:srgbClr val="E9F0FA"/>
-                </a:solidFill>
-                <a:latin typeface="Segoe UI"/>
+              <a:rPr sz="2400" b="1">
+                <a:solidFill>
+                  <a:srgbClr val="ECF2FB"/>
+                </a:solidFill>
+                <a:latin typeface="Segoe UI Semibold"/>
               </a:rPr>
-              <a:t>Same trains, same track. The optimizer keeps total delay down by setting smart precedence at each crossing.</a:t>
-            </a:r>
-          </a:p>
-          <a:p>
-            <a:pPr algn="l">
+              <a:t>unsafe states, ever</a:t>
+            </a:r>
+          </a:p>
+        </p:txBody>
+      </p:sp>
+      <p:sp>
+        <p:nvSpPr>
+          <p:cNvPr id="5" name="TextBox 4"/>
+          <p:cNvSpPr txBox="1"/>
+          <p:nvPr/>
+        </p:nvSpPr>
+        <p:spPr>
+          <a:xfrm>
+            <a:off x="1737360" y="5166360"/>
+            <a:ext cx="8686800" cy="914400"/>
+          </a:xfrm>
+          <a:prstGeom prst="rect">
+            <a:avLst/>
+          </a:prstGeom>
+          <a:noFill/>
+        </p:spPr>
+        <p:txBody>
+          <a:bodyPr wrap="square" anchor="t">
+            <a:spAutoFit/>
+          </a:bodyPr>
+          <a:lstStyle/>
+          <a:p>
+            <a:pPr algn="ctr">
               <a:spcAft>
-                <a:spcPts val="1400"/>
+                <a:spcPts val="800"/>
               </a:spcAft>
             </a:pPr>
             <a:r>
-              <a:rPr sz="2000" b="0">
-                <a:solidFill>
-                  <a:srgbClr val="22D37A"/>
-                </a:solidFill>
-                <a:latin typeface="Segoe UI"/>
+              <a:rPr sz="1500" b="0">
+                <a:solidFill>
+                  <a:srgbClr val="9AB0CF"/>
+                </a:solidFill>
+                <a:latin typeface="Segoe UI Semibold"/>
               </a:rPr>
-              <a:t>About 20% less delay than the manual first-come-first-served baseline.</a:t>
-            </a:r>
-          </a:p>
-          <a:p>
-            <a:pPr algn="l">
-              <a:spcAft>
-                <a:spcPts val="1400"/>
-              </a:spcAft>
-            </a:pPr>
-            <a:r>
-              <a:rPr sz="2000" b="0">
-                <a:solidFill>
-                  <a:srgbClr val="9AB0CF"/>
-                </a:solidFill>
-                <a:latin typeface="Segoe UI"/>
-              </a:rPr>
-              <a:t>It does not move more trains. It protects the important ones, spending a goods train's minutes to save a Superfast's.</a:t>
-            </a:r>
-          </a:p>
-          <a:p>
-            <a:pPr algn="l">
-              <a:spcAft>
-                <a:spcPts val="1400"/>
-              </a:spcAft>
-            </a:pPr>
-            <a:r>
-              <a:rPr sz="2000" b="0">
-                <a:solidFill>
-                  <a:srgbClr val="9AB0CF"/>
-                </a:solidFill>
-                <a:latin typeface="Segoe UI"/>
-              </a:rPr>
-              <a:t>13 conflicts resolved automatically, zero unsafe states. Measured by the test suite.</a:t>
+              <a:t>A separate interlocking layer makes a collision impossible, no matter what the AI wants. Balasore, 2023: a route like that killed nearly 300 people.</a:t>
             </a:r>
           </a:p>
         </p:txBody>
@@ -5300,56 +4006,13 @@
       <p:grpSpPr/>
       <p:sp>
         <p:nvSpPr>
-          <p:cNvPr id="2" name="Rectangle 1"/>
-          <p:cNvSpPr/>
-          <p:nvPr/>
-        </p:nvSpPr>
-        <p:spPr>
-          <a:xfrm>
-            <a:off x="0" y="0"/>
-            <a:ext cx="128016" cy="6858000"/>
-          </a:xfrm>
-          <a:prstGeom prst="rect">
-            <a:avLst/>
-          </a:prstGeom>
-          <a:solidFill>
-            <a:srgbClr val="22D37A"/>
-          </a:solidFill>
-          <a:ln>
-            <a:noFill/>
-          </a:ln>
-        </p:spPr>
-        <p:style>
-          <a:lnRef idx="1">
-            <a:schemeClr val="accent1"/>
-          </a:lnRef>
-          <a:fillRef idx="3">
-            <a:schemeClr val="accent1"/>
-          </a:fillRef>
-          <a:effectRef idx="2">
-            <a:schemeClr val="accent1"/>
-          </a:effectRef>
-          <a:fontRef idx="minor">
-            <a:schemeClr val="lt1"/>
-          </a:fontRef>
-        </p:style>
-        <p:txBody>
-          <a:bodyPr rtlCol="0" anchor="ctr"/>
-          <a:lstStyle/>
-          <a:p>
-            <a:pPr algn="ctr"/>
-          </a:p>
-        </p:txBody>
-      </p:sp>
-      <p:sp>
-        <p:nvSpPr>
-          <p:cNvPr id="3" name="TextBox 2"/>
+          <p:cNvPr id="2" name="TextBox 1"/>
           <p:cNvSpPr txBox="1"/>
           <p:nvPr/>
         </p:nvSpPr>
         <p:spPr>
           <a:xfrm>
-            <a:off x="640080" y="457200"/>
+            <a:off x="731520" y="640080"/>
             <a:ext cx="10972800" cy="457200"/>
           </a:xfrm>
           <a:prstGeom prst="rect">
@@ -5375,21 +4038,21 @@
                 </a:solidFill>
                 <a:latin typeface="Consolas"/>
               </a:rPr>
-              <a:t>WHAT MAKES IT DIFFERENT</a:t>
-            </a:r>
-          </a:p>
-        </p:txBody>
-      </p:sp>
-      <p:sp>
-        <p:nvSpPr>
-          <p:cNvPr id="4" name="TextBox 3"/>
+              <a:t>WHY THIS MATTERS</a:t>
+            </a:r>
+          </a:p>
+        </p:txBody>
+      </p:sp>
+      <p:sp>
+        <p:nvSpPr>
+          <p:cNvPr id="3" name="TextBox 2"/>
           <p:cNvSpPr txBox="1"/>
           <p:nvPr/>
         </p:nvSpPr>
         <p:spPr>
           <a:xfrm>
-            <a:off x="640080" y="868680"/>
-            <a:ext cx="10972800" cy="1188720"/>
+            <a:off x="731520" y="1097280"/>
+            <a:ext cx="10972800" cy="1097280"/>
           </a:xfrm>
           <a:prstGeom prst="rect">
             <a:avLst/>
@@ -5408,27 +4071,27 @@
               </a:spcAft>
             </a:pPr>
             <a:r>
-              <a:rPr sz="3200" b="1">
-                <a:solidFill>
-                  <a:srgbClr val="E9F0FA"/>
-                </a:solidFill>
-                <a:latin typeface="Segoe UI"/>
+              <a:rPr sz="3600" b="1">
+                <a:solidFill>
+                  <a:srgbClr val="ECF2FB"/>
+                </a:solidFill>
+                <a:latin typeface="Segoe UI Semibold"/>
               </a:rPr>
-              <a:t>It explains every call in plain words</a:t>
-            </a:r>
-          </a:p>
-        </p:txBody>
-      </p:sp>
-      <p:sp>
-        <p:nvSpPr>
-          <p:cNvPr id="5" name="TextBox 4"/>
+              <a:t>Closed crore-scale systems, or nothing</a:t>
+            </a:r>
+          </a:p>
+        </p:txBody>
+      </p:sp>
+      <p:sp>
+        <p:nvSpPr>
+          <p:cNvPr id="4" name="TextBox 3"/>
           <p:cNvSpPr txBox="1"/>
           <p:nvPr/>
         </p:nvSpPr>
         <p:spPr>
           <a:xfrm>
-            <a:off x="640080" y="1828800"/>
-            <a:ext cx="5212080" cy="4206240"/>
+            <a:off x="731520" y="2468880"/>
+            <a:ext cx="10607040" cy="3657600"/>
           </a:xfrm>
           <a:prstGeom prst="rect">
             <a:avLst/>
@@ -5443,77 +4106,69 @@
           <a:p>
             <a:pPr algn="l">
               <a:spcAft>
-                <a:spcPts val="1400"/>
+                <a:spcPts val="1600"/>
               </a:spcAft>
             </a:pPr>
             <a:r>
-              <a:rPr sz="1700" b="0">
-                <a:solidFill>
-                  <a:srgbClr val="E9F0FA"/>
-                </a:solidFill>
-                <a:latin typeface="Segoe UI"/>
+              <a:rPr sz="1900" b="0">
+                <a:solidFill>
+                  <a:srgbClr val="ECF2FB"/>
+                </a:solidFill>
+                <a:latin typeface="Segoe UI Semibold"/>
               </a:rPr>
-              <a:t>Every decision is the optimizer's own working, written out. Nothing is invented.</a:t>
+              <a:t>Indian Railways still dispatches every crossing by hand. Punctuality fell from 94% to about 74% in three years.</a:t>
             </a:r>
           </a:p>
           <a:p>
             <a:pPr algn="l">
               <a:spcAft>
-                <a:spcPts val="1400"/>
+                <a:spcPts val="1600"/>
               </a:spcAft>
             </a:pPr>
             <a:r>
-              <a:rPr sz="1700" b="0">
-                <a:solidFill>
-                  <a:srgbClr val="22D37A"/>
-                </a:solidFill>
-                <a:latin typeface="Segoe UI"/>
+              <a:rPr sz="1900" b="0">
+                <a:solidFill>
+                  <a:srgbClr val="9AB0CF"/>
+                </a:solidFill>
+                <a:latin typeface="Segoe UI Semibold"/>
               </a:rPr>
-              <a:t>"Held the Express 11 min so the Superfast could cross. Reversing it would cost 1.7 times more."</a:t>
+              <a:t>The AI systems that exist (Hitachi, Siemens, Alstom) are closed, cost over a thousand crore, and stay advisory because controllers do not trust a black box.</a:t>
             </a:r>
           </a:p>
           <a:p>
             <a:pPr algn="l">
               <a:spcAft>
-                <a:spcPts val="1400"/>
+                <a:spcPts val="1600"/>
               </a:spcAft>
             </a:pPr>
             <a:r>
-              <a:rPr sz="1700" b="0">
+              <a:rPr sz="1900" b="0">
+                <a:solidFill>
+                  <a:srgbClr val="22D37A"/>
+                </a:solidFill>
+                <a:latin typeface="Segoe UI Semibold"/>
+              </a:rPr>
+              <a:t>Nothing open, explainable, and India-specific exists. That is the gap.</a:t>
+            </a:r>
+          </a:p>
+          <a:p>
+            <a:pPr algn="l">
+              <a:spcAft>
+                <a:spcPts val="1600"/>
+              </a:spcAft>
+            </a:pPr>
+            <a:r>
+              <a:rPr sz="1900" b="0">
                 <a:solidFill>
                   <a:srgbClr val="9AB0CF"/>
                 </a:solidFill>
-                <a:latin typeface="Segoe UI"/>
+                <a:latin typeface="Segoe UI Semibold"/>
               </a:rPr>
-              <a:t>This answers why AI dispatching is not adopted today: controllers do not trust black boxes.</a:t>
-            </a:r>
-          </a:p>
-        </p:txBody>
-      </p:sp>
-      <p:pic>
-        <p:nvPicPr>
-          <p:cNvPr id="6" name="Picture 5" descr="glass-box.png"/>
-          <p:cNvPicPr>
-            <a:picLocks noChangeAspect="1"/>
-          </p:cNvPicPr>
-          <p:nvPr/>
-        </p:nvPicPr>
-        <p:blipFill>
-          <a:blip r:embed="rId2"/>
-          <a:stretch>
-            <a:fillRect/>
-          </a:stretch>
-        </p:blipFill>
-        <p:spPr>
-          <a:xfrm>
-            <a:off x="6126480" y="1554480"/>
-            <a:ext cx="5486400" cy="12563856"/>
-          </a:xfrm>
-          <a:prstGeom prst="rect">
-            <a:avLst/>
-          </a:prstGeom>
-        </p:spPr>
-      </p:pic>
+              <a:t>We did not use reinforcement learning, on purpose: the evidence shows classical optimization beats it and RL has never been deployed.</a:t>
+            </a:r>
+          </a:p>
+        </p:txBody>
+      </p:sp>
     </p:spTree>
   </p:cSld>
   <p:clrMapOvr>
@@ -5542,56 +4197,13 @@
       <p:grpSpPr/>
       <p:sp>
         <p:nvSpPr>
-          <p:cNvPr id="2" name="Rectangle 1"/>
-          <p:cNvSpPr/>
-          <p:nvPr/>
-        </p:nvSpPr>
-        <p:spPr>
-          <a:xfrm>
-            <a:off x="0" y="0"/>
-            <a:ext cx="128016" cy="6858000"/>
-          </a:xfrm>
-          <a:prstGeom prst="rect">
-            <a:avLst/>
-          </a:prstGeom>
-          <a:solidFill>
-            <a:srgbClr val="3AA0FF"/>
-          </a:solidFill>
-          <a:ln>
-            <a:noFill/>
-          </a:ln>
-        </p:spPr>
-        <p:style>
-          <a:lnRef idx="1">
-            <a:schemeClr val="accent1"/>
-          </a:lnRef>
-          <a:fillRef idx="3">
-            <a:schemeClr val="accent1"/>
-          </a:fillRef>
-          <a:effectRef idx="2">
-            <a:schemeClr val="accent1"/>
-          </a:effectRef>
-          <a:fontRef idx="minor">
-            <a:schemeClr val="lt1"/>
-          </a:fontRef>
-        </p:style>
-        <p:txBody>
-          <a:bodyPr rtlCol="0" anchor="ctr"/>
-          <a:lstStyle/>
-          <a:p>
-            <a:pPr algn="ctr"/>
-          </a:p>
-        </p:txBody>
-      </p:sp>
-      <p:sp>
-        <p:nvSpPr>
-          <p:cNvPr id="3" name="TextBox 2"/>
+          <p:cNvPr id="2" name="TextBox 1"/>
           <p:cNvSpPr txBox="1"/>
           <p:nvPr/>
         </p:nvSpPr>
         <p:spPr>
           <a:xfrm>
-            <a:off x="640080" y="457200"/>
+            <a:off x="731520" y="640080"/>
             <a:ext cx="10972800" cy="457200"/>
           </a:xfrm>
           <a:prstGeom prst="rect">
@@ -5617,21 +4229,21 @@
                 </a:solidFill>
                 <a:latin typeface="Consolas"/>
               </a:rPr>
-              <a:t>YOU CAN QUESTION IT</a:t>
-            </a:r>
-          </a:p>
-        </p:txBody>
-      </p:sp>
-      <p:sp>
-        <p:nvSpPr>
-          <p:cNvPr id="4" name="TextBox 3"/>
+              <a:t>HOW REAL, HOW IT WORKS</a:t>
+            </a:r>
+          </a:p>
+        </p:txBody>
+      </p:sp>
+      <p:sp>
+        <p:nvSpPr>
+          <p:cNvPr id="3" name="TextBox 2"/>
           <p:cNvSpPr txBox="1"/>
           <p:nvPr/>
         </p:nvSpPr>
         <p:spPr>
           <a:xfrm>
-            <a:off x="640080" y="868680"/>
-            <a:ext cx="10972800" cy="1188720"/>
+            <a:off x="731520" y="1097280"/>
+            <a:ext cx="10972800" cy="1097280"/>
           </a:xfrm>
           <a:prstGeom prst="rect">
             <a:avLst/>
@@ -5650,27 +4262,27 @@
               </a:spcAft>
             </a:pPr>
             <a:r>
-              <a:rPr sz="3200" b="1">
-                <a:solidFill>
-                  <a:srgbClr val="E9F0FA"/>
-                </a:solidFill>
-                <a:latin typeface="Segoe UI"/>
+              <a:rPr sz="3600" b="1">
+                <a:solidFill>
+                  <a:srgbClr val="ECF2FB"/>
+                </a:solidFill>
+                <a:latin typeface="Segoe UI Semibold"/>
               </a:rPr>
-              <a:t>Ask the dispatcher anything, offline</a:t>
-            </a:r>
-          </a:p>
-        </p:txBody>
-      </p:sp>
-      <p:sp>
-        <p:nvSpPr>
-          <p:cNvPr id="5" name="TextBox 4"/>
+              <a:t>Real data, two honest layers</a:t>
+            </a:r>
+          </a:p>
+        </p:txBody>
+      </p:sp>
+      <p:sp>
+        <p:nvSpPr>
+          <p:cNvPr id="4" name="TextBox 3"/>
           <p:cNvSpPr txBox="1"/>
           <p:nvPr/>
         </p:nvSpPr>
         <p:spPr>
           <a:xfrm>
-            <a:off x="640080" y="1828800"/>
-            <a:ext cx="5212080" cy="4206240"/>
+            <a:off x="731520" y="2468880"/>
+            <a:ext cx="10607040" cy="3657600"/>
           </a:xfrm>
           <a:prstGeom prst="rect">
             <a:avLst/>
@@ -5685,77 +4297,69 @@
           <a:p>
             <a:pPr algn="l">
               <a:spcAft>
-                <a:spcPts val="1400"/>
+                <a:spcPts val="1600"/>
               </a:spcAft>
             </a:pPr>
             <a:r>
-              <a:rPr sz="1700" b="0">
-                <a:solidFill>
-                  <a:srgbClr val="E9F0FA"/>
-                </a:solidFill>
-                <a:latin typeface="Segoe UI"/>
+              <a:rPr sz="1900" b="0">
+                <a:solidFill>
+                  <a:srgbClr val="22D37A"/>
+                </a:solidFill>
+                <a:latin typeface="Segoe UI Semibold"/>
               </a:rPr>
-              <a:t>"Why is 12801 held?"  "Is the section safe?"  "What would an override cost?"</a:t>
+              <a:t>8,697 real Indian stations and real timetabled services, from the open datameet dataset.</a:t>
             </a:r>
           </a:p>
           <a:p>
             <a:pPr algn="l">
               <a:spcAft>
-                <a:spcPts val="1400"/>
+                <a:spcPts val="1600"/>
               </a:spcAft>
             </a:pPr>
             <a:r>
-              <a:rPr sz="1700" b="0">
-                <a:solidFill>
-                  <a:srgbClr val="9AB0CF"/>
-                </a:solidFill>
-                <a:latin typeface="Segoe UI"/>
+              <a:rPr sz="1900" b="0">
+                <a:solidFill>
+                  <a:srgbClr val="ECF2FB"/>
+                </a:solidFill>
+                <a:latin typeface="Segoe UI Semibold"/>
               </a:rPr>
-              <a:t>Answers come from the same decision trace. No network call, so the demo cannot break.</a:t>
+              <a:t>Interlocking layer: one train per block, single lines locked to one direction. Unsafe states impossible, in code.</a:t>
             </a:r>
           </a:p>
           <a:p>
             <a:pPr algn="l">
               <a:spcAft>
-                <a:spcPts val="1400"/>
+                <a:spcPts val="1600"/>
               </a:spcAft>
             </a:pPr>
             <a:r>
-              <a:rPr sz="1700" b="0">
+              <a:rPr sz="1900" b="0">
+                <a:solidFill>
+                  <a:srgbClr val="ECF2FB"/>
+                </a:solidFill>
+                <a:latin typeface="Segoe UI Semibold"/>
+              </a:rPr>
+              <a:t>Dispatcher layer: the AI only orders moves that are already safe, and writes down a full trace.</a:t>
+            </a:r>
+          </a:p>
+          <a:p>
+            <a:pPr algn="l">
+              <a:spcAft>
+                <a:spcPts val="1600"/>
+              </a:spcAft>
+            </a:pPr>
+            <a:r>
+              <a:rPr sz="1900" b="0">
                 <a:solidFill>
                   <a:srgbClr val="9AB0CF"/>
                 </a:solidFill>
-                <a:latin typeface="Segoe UI"/>
+                <a:latin typeface="Segoe UI Semibold"/>
               </a:rPr>
-              <a:t>The controller stays in charge. The machine just shows the cost of each choice.</a:t>
-            </a:r>
-          </a:p>
-        </p:txBody>
-      </p:sp>
-      <p:pic>
-        <p:nvPicPr>
-          <p:cNvPr id="6" name="Picture 5" descr="glass-box.png"/>
-          <p:cNvPicPr>
-            <a:picLocks noChangeAspect="1"/>
-          </p:cNvPicPr>
-          <p:nvPr/>
-        </p:nvPicPr>
-        <p:blipFill>
-          <a:blip r:embed="rId2"/>
-          <a:stretch>
-            <a:fillRect/>
-          </a:stretch>
-        </p:blipFill>
-        <p:spPr>
-          <a:xfrm>
-            <a:off x="6126480" y="1554480"/>
-            <a:ext cx="5486400" cy="12563856"/>
-          </a:xfrm>
-          <a:prstGeom prst="rect">
-            <a:avLst/>
-          </a:prstGeom>
-        </p:spPr>
-      </p:pic>
+              <a:t>Pure TypeScript, runs in the browser, 12 passing tests. Movement is simulated; India has no open live feed, and the engine is built to take one.</a:t>
+            </a:r>
+          </a:p>
+        </p:txBody>
+      </p:sp>
     </p:spTree>
   </p:cSld>
   <p:clrMapOvr>
@@ -5784,57 +4388,14 @@
       <p:grpSpPr/>
       <p:sp>
         <p:nvSpPr>
-          <p:cNvPr id="2" name="Rectangle 1"/>
-          <p:cNvSpPr/>
-          <p:nvPr/>
-        </p:nvSpPr>
-        <p:spPr>
-          <a:xfrm>
-            <a:off x="0" y="0"/>
-            <a:ext cx="128016" cy="6858000"/>
-          </a:xfrm>
-          <a:prstGeom prst="rect">
-            <a:avLst/>
-          </a:prstGeom>
-          <a:solidFill>
-            <a:srgbClr val="FF4D4D"/>
-          </a:solidFill>
-          <a:ln>
-            <a:noFill/>
-          </a:ln>
-        </p:spPr>
-        <p:style>
-          <a:lnRef idx="1">
-            <a:schemeClr val="accent1"/>
-          </a:lnRef>
-          <a:fillRef idx="3">
-            <a:schemeClr val="accent1"/>
-          </a:fillRef>
-          <a:effectRef idx="2">
-            <a:schemeClr val="accent1"/>
-          </a:effectRef>
-          <a:fontRef idx="minor">
-            <a:schemeClr val="lt1"/>
-          </a:fontRef>
-        </p:style>
-        <p:txBody>
-          <a:bodyPr rtlCol="0" anchor="ctr"/>
-          <a:lstStyle/>
-          <a:p>
-            <a:pPr algn="ctr"/>
-          </a:p>
-        </p:txBody>
-      </p:sp>
-      <p:sp>
-        <p:nvSpPr>
-          <p:cNvPr id="3" name="TextBox 2"/>
+          <p:cNvPr id="2" name="TextBox 1"/>
           <p:cNvSpPr txBox="1"/>
           <p:nvPr/>
         </p:nvSpPr>
         <p:spPr>
           <a:xfrm>
-            <a:off x="640080" y="457200"/>
-            <a:ext cx="10972800" cy="457200"/>
+            <a:off x="822960" y="2194560"/>
+            <a:ext cx="10515600" cy="2743200"/>
           </a:xfrm>
           <a:prstGeom prst="rect">
             <a:avLst/>
@@ -5853,38 +4414,31 @@
               </a:spcAft>
             </a:pPr>
             <a:r>
-              <a:rPr sz="1300" b="1">
-                <a:solidFill>
-                  <a:srgbClr val="FF4D4D"/>
-                </a:solidFill>
-                <a:latin typeface="Consolas"/>
+              <a:rPr sz="4000" b="1">
+                <a:solidFill>
+                  <a:srgbClr val="ECF2FB"/>
+                </a:solidFill>
+                <a:latin typeface="Segoe UI Semibold"/>
               </a:rPr>
-              <a:t>THE SAFETY FLOOR</a:t>
-            </a:r>
-          </a:p>
-        </p:txBody>
-      </p:sp>
-      <p:sp>
-        <p:nvSpPr>
-          <p:cNvPr id="4" name="TextBox 3"/>
-          <p:cNvSpPr txBox="1"/>
-          <p:nvPr/>
-        </p:nvSpPr>
-        <p:spPr>
-          <a:xfrm>
-            <a:off x="640080" y="868680"/>
-            <a:ext cx="10972800" cy="1188720"/>
-          </a:xfrm>
-          <a:prstGeom prst="rect">
-            <a:avLst/>
-          </a:prstGeom>
-          <a:noFill/>
-        </p:spPr>
-        <p:txBody>
-          <a:bodyPr wrap="square" anchor="t">
-            <a:spAutoFit/>
-          </a:bodyPr>
-          <a:lstStyle/>
+              <a:t>Open. Explainable. Safe by design.</a:t>
+            </a:r>
+          </a:p>
+          <a:p>
+            <a:pPr algn="l">
+              <a:spcAft>
+                <a:spcPts val="1800"/>
+              </a:spcAft>
+            </a:pPr>
+            <a:r>
+              <a:rPr sz="1900" b="1">
+                <a:solidFill>
+                  <a:srgbClr val="22D37A"/>
+                </a:solidFill>
+                <a:latin typeface="Segoe UI Semibold"/>
+              </a:rPr>
+              <a:t>The control-room brain Indian Railways does not have yet. Answers problem statement SIH25022.</a:t>
+            </a:r>
+          </a:p>
           <a:p>
             <a:pPr algn="l">
               <a:spcAft>
@@ -5892,27 +4446,27 @@
               </a:spcAft>
             </a:pPr>
             <a:r>
-              <a:rPr sz="3200" b="1">
-                <a:solidFill>
-                  <a:srgbClr val="E9F0FA"/>
-                </a:solidFill>
-                <a:latin typeface="Segoe UI"/>
+              <a:rPr sz="1500" b="0">
+                <a:solidFill>
+                  <a:srgbClr val="9AB0CF"/>
+                </a:solidFill>
+                <a:latin typeface="Segoe UI Semibold"/>
               </a:rPr>
-              <a:t>It cannot cause a collision, by design</a:t>
-            </a:r>
-          </a:p>
-        </p:txBody>
-      </p:sp>
-      <p:sp>
-        <p:nvSpPr>
-          <p:cNvPr id="5" name="TextBox 4"/>
+              <a:t>Try it live, then read the code.</a:t>
+            </a:r>
+          </a:p>
+        </p:txBody>
+      </p:sp>
+      <p:sp>
+        <p:nvSpPr>
+          <p:cNvPr id="3" name="TextBox 2"/>
           <p:cNvSpPr txBox="1"/>
           <p:nvPr/>
         </p:nvSpPr>
         <p:spPr>
           <a:xfrm>
-            <a:off x="640080" y="1828800"/>
-            <a:ext cx="5120640" cy="4206240"/>
+            <a:off x="640080" y="6419088"/>
+            <a:ext cx="10972800" cy="365760"/>
           </a:xfrm>
           <a:prstGeom prst="rect">
             <a:avLst/>
@@ -5927,77 +4481,21 @@
           <a:p>
             <a:pPr algn="l">
               <a:spcAft>
-                <a:spcPts val="1400"/>
+                <a:spcPts val="800"/>
               </a:spcAft>
             </a:pPr>
             <a:r>
-              <a:rPr sz="1600" b="0">
-                <a:solidFill>
-                  <a:srgbClr val="E9F0FA"/>
-                </a:solidFill>
-                <a:latin typeface="Segoe UI"/>
+              <a:rPr sz="1050" b="0">
+                <a:solidFill>
+                  <a:srgbClr val="9AB0CF"/>
+                </a:solidFill>
+                <a:latin typeface="Consolas"/>
               </a:rPr>
-              <a:t>A separate interlocking layer enforces one train per block and locks single lines to one direction, no matter what the AI does.</a:t>
-            </a:r>
-          </a:p>
-          <a:p>
-            <a:pPr algn="l">
-              <a:spcAft>
-                <a:spcPts val="1400"/>
-              </a:spcAft>
-            </a:pPr>
-            <a:r>
-              <a:rPr sz="1600" b="0">
-                <a:solidFill>
-                  <a:srgbClr val="FF4D4D"/>
-                </a:solidFill>
-                <a:latin typeface="Segoe UI"/>
-              </a:rPr>
-              <a:t>Re-stage the Balasore failure: a route set toward an occupied line is refused.</a:t>
-            </a:r>
-          </a:p>
-          <a:p>
-            <a:pPr algn="l">
-              <a:spcAft>
-                <a:spcPts val="1400"/>
-              </a:spcAft>
-            </a:pPr>
-            <a:r>
-              <a:rPr sz="1600" b="0">
-                <a:solidFill>
-                  <a:srgbClr val="9AB0CF"/>
-                </a:solidFill>
-                <a:latin typeface="Segoe UI"/>
-              </a:rPr>
-              <a:t>Safety is a hard floor. The AI only optimizes inside what is already safe.</a:t>
-            </a:r>
-          </a:p>
-        </p:txBody>
-      </p:sp>
-      <p:pic>
-        <p:nvPicPr>
-          <p:cNvPr id="6" name="Picture 5" descr="safety-hold.png"/>
-          <p:cNvPicPr>
-            <a:picLocks noChangeAspect="1"/>
-          </p:cNvPicPr>
-          <p:nvPr/>
-        </p:nvPicPr>
-        <p:blipFill>
-          <a:blip r:embed="rId2"/>
-          <a:stretch>
-            <a:fillRect/>
-          </a:stretch>
-        </p:blipFill>
-        <p:spPr>
-          <a:xfrm>
-            <a:off x="6035040" y="1554480"/>
-            <a:ext cx="5577840" cy="3486150"/>
-          </a:xfrm>
-          <a:prstGeom prst="rect">
-            <a:avLst/>
-          </a:prstGeom>
-        </p:spPr>
-      </p:pic>
+              <a:t>LIVE  garvitsurana271.github.io/pravaah      CODE  github.com/garvitsurana271/pravaah      FAR AWAY 2026</a:t>
+            </a:r>
+          </a:p>
+        </p:txBody>
+      </p:sp>
     </p:spTree>
   </p:cSld>
   <p:clrMapOvr>

</xml_diff>

<commit_message>
Add click-to-focus map (ATC-style zoom), proper track-switch logo + favicon, LICENSE (MIT), .gitattributes; remove debug artifacts + old deck script
</commit_message>
<xml_diff>
--- a/Pravaah-Deck.pptx
+++ b/Pravaah-Deck.pptx
@@ -14,6 +14,7 @@
     <p:sldId id="262" r:id="rId13"/>
     <p:sldId id="263" r:id="rId14"/>
     <p:sldId id="264" r:id="rId15"/>
+    <p:sldId id="265" r:id="rId16"/>
   </p:sldIdLst>
   <p:sldSz cx="12191695" cy="6858000" type="screen4x3"/>
   <p:notesSz cx="6858000" cy="9144000"/>
@@ -3099,6 +3100,48 @@
       <p:pic>
         <p:nvPicPr>
           <p:cNvPr id="2" name="Picture 1" descr="slide-preview-1.png"/>
+          <p:cNvPicPr>
+            <a:picLocks noChangeAspect="1"/>
+          </p:cNvPicPr>
+          <p:nvPr/>
+        </p:nvPicPr>
+        <p:blipFill>
+          <a:blip r:embed="rId2"/>
+          <a:stretch>
+            <a:fillRect/>
+          </a:stretch>
+        </p:blipFill>
+        <p:spPr>
+          <a:xfrm>
+            <a:off x="0" y="0"/>
+            <a:ext cx="12191695" cy="6858000"/>
+          </a:xfrm>
+          <a:prstGeom prst="rect">
+            <a:avLst/>
+          </a:prstGeom>
+        </p:spPr>
+      </p:pic>
+    </p:spTree>
+  </p:cSld>
+  <p:clrMapOvr>
+    <a:masterClrMapping/>
+  </p:clrMapOvr>
+</p:sld>
+</file>
+
+<file path=ppt/slides/slide10.xml><?xml version="1.0" encoding="utf-8"?>
+<p:sld xmlns:a="http://schemas.openxmlformats.org/drawingml/2006/main" xmlns:p="http://schemas.openxmlformats.org/presentationml/2006/main" xmlns:r="http://schemas.openxmlformats.org/officeDocument/2006/relationships">
+  <p:cSld>
+    <p:spTree>
+      <p:nvGrpSpPr>
+        <p:cNvPr id="1" name=""/>
+        <p:cNvGrpSpPr/>
+        <p:nvPr/>
+      </p:nvGrpSpPr>
+      <p:grpSpPr/>
+      <p:pic>
+        <p:nvPicPr>
+          <p:cNvPr id="2" name="Picture 1" descr="slide-preview-10.png"/>
           <p:cNvPicPr>
             <a:picLocks noChangeAspect="1"/>
           </p:cNvPicPr>

</xml_diff>